<commit_message>
Use Arial and fix font charset hints so Persian text renders without Vazirmatn
Co-Authored-By: Claude Sonnet 5.5 <noreply@anthropic.com>
Claude-Session: https://claude.ai/code/session_018eMZXBKLzeFCo2o1NXtn4j
</commit_message>
<xml_diff>
--- a/webinar-slides/Webinar_Authentic_Anger_Self_Attack_Rumination.pptx
+++ b/webinar-slides/Webinar_Authentic_Anger_Self_Attack_Rumination.pptx
@@ -127,19 +127,19 @@
   <p:extLst>
     <p:ext uri="{521415D9-36F7-43E2-AB2F-B90AF26B5E84}">
       <p14:sectionLst xmlns:p14="http://schemas.microsoft.com/office/powerpoint/2010/main">
-        <p14:section name="آغاز" id="{a376211a-cfe0-42dc-beaa-2d477ad45ea5}">
+        <p14:section name="آغاز" id="{a944c114-a537-a6ee-b899-ae3f0de82f76}">
           <p14:sldIdLst>
             <p14:sldId id="256"/>
             <p14:sldId id="257"/>
             <p14:sldId id="258"/>
           </p14:sldIdLst>
         </p14:section>
-        <p14:section name="خشم" id="{d3791115-739c-4cd1-9122-9a0933647498}">
+        <p14:section name="خشم" id="{f2a78d72-e90e-195c-f8a8-40aac0789d27}">
           <p14:sldIdLst>
             <p14:sldId id="259"/>
           </p14:sldIdLst>
         </p14:section>
-        <p14:section name="منتقد درونی" id="{ec2b1a91-6365-df05-51de-a28cb4c3bc6a}">
+        <p14:section name="منتقد درونی" id="{0cc0d77d-2d32-42a4-0afe-aa3a360155c1}">
           <p14:sldIdLst>
             <p14:sldId id="260"/>
             <p14:sldId id="261"/>
@@ -148,7 +148,7 @@
             <p14:sldId id="264"/>
           </p14:sldIdLst>
         </p14:section>
-        <p14:section name="نشخوار فکری" id="{c0278e9a-0f9d-69d3-7640-e00242376070}">
+        <p14:section name="نشخوار فکری" id="{fd3eb2f0-0518-6b9c-77c0-634c2c8fd2b3}">
           <p14:sldIdLst>
             <p14:sldId id="265"/>
             <p14:sldId id="266"/>
@@ -157,7 +157,7 @@
             <p14:sldId id="269"/>
           </p14:sldIdLst>
         </p14:section>
-        <p14:section name="نقشه و مسیر" id="{afa94081-c2b3-f464-5722-8a8e50870e26}">
+        <p14:section name="نقشه و مسیر" id="{9e6f42a2-37a6-421b-9376-f2b64808884c}">
           <p14:sldIdLst>
             <p14:sldId id="270"/>
             <p14:sldId id="271"/>
@@ -166,7 +166,7 @@
             <p14:sldId id="274"/>
           </p14:sldIdLst>
         </p14:section>
-        <p14:section name="پایان" id="{186b305e-5edd-578a-47e4-d45757980238}">
+        <p14:section name="پایان" id="{afa9e910-5f75-d03d-173d-d5b8e80a0f28}">
           <p14:sldIdLst>
             <p14:sldId id="275"/>
             <p14:sldId id="276"/>
@@ -2642,9 +2642,8 @@
                 <a:solidFill>
                   <a:schemeClr val="tx2"/>
                 </a:solidFill>
-                <a:latin typeface="Vazirmatn" pitchFamily="34" charset="0"/>
-                <a:ea typeface="Vazirmatn" pitchFamily="34" charset="-122"/>
-                <a:cs typeface="Vazirmatn" pitchFamily="34" charset="-120"/>
+                <a:latin typeface="Arial" pitchFamily="34" charset="0"/>
+                <a:cs typeface="Arial" pitchFamily="34" charset="178"/>
               </a:defRPr>
             </a:lvl1pPr>
           </a:lstStyle>
@@ -2688,9 +2687,8 @@
                 <a:solidFill>
                   <a:schemeClr val="accent5"/>
                 </a:solidFill>
-                <a:latin typeface="Vazirmatn"/>
-                <a:ea typeface="Vazirmatn"/>
-                <a:cs typeface="Vazirmatn"/>
+                <a:latin typeface="Arial"/>
+                <a:cs typeface="Arial"/>
               </a:defRPr>
             </a:lvl1pPr>
           </a:lstStyle>
@@ -2768,9 +2766,8 @@
                 <a:solidFill>
                   <a:schemeClr val="accent5"/>
                 </a:solidFill>
-                <a:latin typeface="Vazirmatn"/>
-                <a:ea typeface="Vazirmatn"/>
-                <a:cs typeface="Vazirmatn"/>
+                <a:latin typeface="Arial"/>
+                <a:cs typeface="Arial"/>
               </a:defRPr>
             </a:lvl1pPr>
           </a:lstStyle>
@@ -2844,9 +2841,8 @@
                 <a:solidFill>
                   <a:schemeClr val="bg1"/>
                 </a:solidFill>
-                <a:latin typeface="Vazirmatn" pitchFamily="34" charset="0"/>
-                <a:ea typeface="Vazirmatn" pitchFamily="34" charset="-122"/>
-                <a:cs typeface="Vazirmatn" pitchFamily="34" charset="-120"/>
+                <a:latin typeface="Arial" pitchFamily="34" charset="0"/>
+                <a:cs typeface="Arial" pitchFamily="34" charset="178"/>
               </a:defRPr>
             </a:lvl1pPr>
           </a:lstStyle>
@@ -2890,9 +2886,8 @@
                 <a:solidFill>
                   <a:schemeClr val="bg1"/>
                 </a:solidFill>
-                <a:latin typeface="Vazirmatn"/>
-                <a:ea typeface="Vazirmatn"/>
-                <a:cs typeface="Vazirmatn"/>
+                <a:latin typeface="Arial"/>
+                <a:cs typeface="Arial"/>
               </a:defRPr>
             </a:lvl1pPr>
           </a:lstStyle>
@@ -2963,9 +2958,8 @@
                 <a:solidFill>
                   <a:schemeClr val="accent5"/>
                 </a:solidFill>
-                <a:latin typeface="Vazirmatn"/>
-                <a:ea typeface="Vazirmatn"/>
-                <a:cs typeface="Vazirmatn"/>
+                <a:latin typeface="Arial"/>
+                <a:cs typeface="Arial"/>
               </a:defRPr>
             </a:lvl1pPr>
           </a:lstStyle>
@@ -3292,9 +3286,8 @@
                 <a:solidFill>
                   <a:schemeClr val="tx2"/>
                 </a:solidFill>
-                <a:latin typeface="Vazirmatn" pitchFamily="34" charset="0"/>
-                <a:ea typeface="Vazirmatn" pitchFamily="34" charset="-122"/>
-                <a:cs typeface="Vazirmatn" pitchFamily="34" charset="-120"/>
+                <a:latin typeface="Arial" pitchFamily="34" charset="0"/>
+                <a:cs typeface="Arial" pitchFamily="34" charset="178"/>
               </a:rPr>
               <a:t>چرا وقتی حق داریم عصبانی باشیم،</a:t>
             </a:r>
@@ -3312,9 +3305,8 @@
                 <a:solidFill>
                   <a:schemeClr val="tx2"/>
                 </a:solidFill>
-                <a:latin typeface="Vazirmatn" pitchFamily="34" charset="0"/>
-                <a:ea typeface="Vazirmatn" pitchFamily="34" charset="-122"/>
-                <a:cs typeface="Vazirmatn" pitchFamily="34" charset="-120"/>
+                <a:latin typeface="Arial" pitchFamily="34" charset="0"/>
+                <a:cs typeface="Arial" pitchFamily="34" charset="178"/>
               </a:rPr>
               <a:t>خودمان را سرزنش می‌کنیم؟</a:t>
             </a:r>
@@ -3351,9 +3343,8 @@
                 <a:solidFill>
                   <a:schemeClr val="tx1"/>
                 </a:solidFill>
-                <a:latin typeface="Vazirmatn" pitchFamily="34" charset="0"/>
-                <a:ea typeface="Vazirmatn" pitchFamily="34" charset="-122"/>
-                <a:cs typeface="Vazirmatn" pitchFamily="34" charset="-120"/>
+                <a:latin typeface="Arial" pitchFamily="34" charset="0"/>
+                <a:cs typeface="Arial" pitchFamily="34" charset="178"/>
               </a:rPr>
               <a:t>از خشم اصیل تا خودحمله و نشخوار فکری</a:t>
             </a:r>
@@ -3390,9 +3381,8 @@
                 <a:solidFill>
                   <a:schemeClr val="accent5"/>
                 </a:solidFill>
-                <a:latin typeface="Vazirmatn" pitchFamily="34" charset="0"/>
-                <a:ea typeface="Vazirmatn" pitchFamily="34" charset="-122"/>
-                <a:cs typeface="Vazirmatn" pitchFamily="34" charset="-120"/>
+                <a:latin typeface="Arial" pitchFamily="34" charset="0"/>
+                <a:cs typeface="Arial" pitchFamily="34" charset="178"/>
               </a:rPr>
               <a:t>یک مسیر کاربردی بر پایه سه پژوهش کیفی جدید</a:t>
             </a:r>
@@ -3429,9 +3419,8 @@
                 <a:solidFill>
                   <a:schemeClr val="accent2"/>
                 </a:solidFill>
-                <a:latin typeface="Vazirmatn" pitchFamily="34" charset="0"/>
-                <a:ea typeface="Vazirmatn" pitchFamily="34" charset="-122"/>
-                <a:cs typeface="Vazirmatn" pitchFamily="34" charset="-120"/>
+                <a:latin typeface="Arial" pitchFamily="34" charset="0"/>
+                <a:cs typeface="Arial" pitchFamily="34" charset="178"/>
               </a:rPr>
               <a:t>خشم</a:t>
             </a:r>
@@ -3492,9 +3481,8 @@
                 <a:solidFill>
                   <a:schemeClr val="accent2"/>
                 </a:solidFill>
-                <a:latin typeface="Vazirmatn" pitchFamily="34" charset="0"/>
-                <a:ea typeface="Vazirmatn" pitchFamily="34" charset="-122"/>
-                <a:cs typeface="Vazirmatn" pitchFamily="34" charset="-120"/>
+                <a:latin typeface="Arial" pitchFamily="34" charset="0"/>
+                <a:cs typeface="Arial" pitchFamily="34" charset="178"/>
               </a:rPr>
               <a:t>مرز</a:t>
             </a:r>
@@ -3555,9 +3543,8 @@
                 <a:solidFill>
                   <a:schemeClr val="accent2"/>
                 </a:solidFill>
-                <a:latin typeface="Vazirmatn" pitchFamily="34" charset="0"/>
-                <a:ea typeface="Vazirmatn" pitchFamily="34" charset="-122"/>
-                <a:cs typeface="Vazirmatn" pitchFamily="34" charset="-120"/>
+                <a:latin typeface="Arial" pitchFamily="34" charset="0"/>
+                <a:cs typeface="Arial" pitchFamily="34" charset="178"/>
               </a:rPr>
               <a:t>اقدام</a:t>
             </a:r>
@@ -3594,9 +3581,8 @@
                 <a:solidFill>
                   <a:schemeClr val="accent1"/>
                 </a:solidFill>
-                <a:latin typeface="Vazirmatn" pitchFamily="34" charset="0"/>
-                <a:ea typeface="Vazirmatn" pitchFamily="34" charset="-122"/>
-                <a:cs typeface="Vazirmatn" pitchFamily="34" charset="-120"/>
+                <a:latin typeface="Arial" pitchFamily="34" charset="0"/>
+                <a:cs typeface="Arial" pitchFamily="34" charset="178"/>
               </a:rPr>
               <a:t>خشم</a:t>
             </a:r>
@@ -3657,9 +3643,8 @@
                 <a:solidFill>
                   <a:schemeClr val="accent1"/>
                 </a:solidFill>
-                <a:latin typeface="Vazirmatn" pitchFamily="34" charset="0"/>
-                <a:ea typeface="Vazirmatn" pitchFamily="34" charset="-122"/>
-                <a:cs typeface="Vazirmatn" pitchFamily="34" charset="-120"/>
+                <a:latin typeface="Arial" pitchFamily="34" charset="0"/>
+                <a:cs typeface="Arial" pitchFamily="34" charset="178"/>
               </a:rPr>
               <a:t>خودسرزنشی</a:t>
             </a:r>
@@ -3720,9 +3705,8 @@
                 <a:solidFill>
                   <a:schemeClr val="accent1"/>
                 </a:solidFill>
-                <a:latin typeface="Vazirmatn" pitchFamily="34" charset="0"/>
-                <a:ea typeface="Vazirmatn" pitchFamily="34" charset="-122"/>
-                <a:cs typeface="Vazirmatn" pitchFamily="34" charset="-120"/>
+                <a:latin typeface="Arial" pitchFamily="34" charset="0"/>
+                <a:cs typeface="Arial" pitchFamily="34" charset="178"/>
               </a:rPr>
               <a:t>نشخوار</a:t>
             </a:r>
@@ -3783,9 +3767,8 @@
                 <a:solidFill>
                   <a:schemeClr val="accent1"/>
                 </a:solidFill>
-                <a:latin typeface="Vazirmatn" pitchFamily="34" charset="0"/>
-                <a:ea typeface="Vazirmatn" pitchFamily="34" charset="-122"/>
-                <a:cs typeface="Vazirmatn" pitchFamily="34" charset="-120"/>
+                <a:latin typeface="Arial" pitchFamily="34" charset="0"/>
+                <a:cs typeface="Arial" pitchFamily="34" charset="178"/>
               </a:rPr>
               <a:t>حمله به خود</a:t>
             </a:r>
@@ -3867,9 +3850,8 @@
                 <a:solidFill>
                   <a:schemeClr val="accent5"/>
                 </a:solidFill>
-                <a:latin typeface="Vazirmatn" pitchFamily="34" charset="0"/>
-                <a:ea typeface="Vazirmatn" pitchFamily="34" charset="-122"/>
-                <a:cs typeface="Vazirmatn" pitchFamily="34" charset="-120"/>
+                <a:latin typeface="Arial" pitchFamily="34" charset="0"/>
+                <a:cs typeface="Arial" pitchFamily="34" charset="178"/>
               </a:rPr>
               <a:t>اما چرا بعد از تمام شدن اتفاق، ذهن ادامه می‌دهد؟</a:t>
             </a:r>
@@ -3906,9 +3888,8 @@
                 <a:solidFill>
                   <a:schemeClr val="accent1"/>
                 </a:solidFill>
-                <a:latin typeface="Vazirmatn" pitchFamily="34" charset="0"/>
-                <a:ea typeface="Vazirmatn" pitchFamily="34" charset="-122"/>
-                <a:cs typeface="Vazirmatn" pitchFamily="34" charset="-120"/>
+                <a:latin typeface="Arial" pitchFamily="34" charset="0"/>
+                <a:cs typeface="Arial" pitchFamily="34" charset="178"/>
               </a:rPr>
               <a:t>«من باید بفهمم چرا.»</a:t>
             </a:r>
@@ -3945,9 +3926,8 @@
                 <a:solidFill>
                   <a:schemeClr val="tx1"/>
                 </a:solidFill>
-                <a:latin typeface="Vazirmatn" pitchFamily="34" charset="0"/>
-                <a:ea typeface="Vazirmatn" pitchFamily="34" charset="-122"/>
-                <a:cs typeface="Vazirmatn" pitchFamily="34" charset="-120"/>
+                <a:latin typeface="Arial" pitchFamily="34" charset="0"/>
+                <a:cs typeface="Arial" pitchFamily="34" charset="178"/>
               </a:rPr>
               <a:t>و گاهی این تلاش برای فهمیدن، تبدیل به نشخوار می‌شود.</a:t>
             </a:r>
@@ -3987,9 +3967,8 @@
                 <a:solidFill>
                   <a:schemeClr val="accent5"/>
                 </a:solidFill>
-                <a:latin typeface="Vazirmatn"/>
-                <a:ea typeface="Vazirmatn"/>
-                <a:cs typeface="Vazirmatn"/>
+                <a:latin typeface="Arial"/>
+                <a:cs typeface="Arial"/>
               </a:defRPr>
             </a:lvl1pPr>
           </a:lstStyle>
@@ -4059,9 +4038,8 @@
                 <a:solidFill>
                   <a:schemeClr val="tx2"/>
                 </a:solidFill>
-                <a:latin typeface="Vazirmatn" pitchFamily="34" charset="0"/>
-                <a:ea typeface="Vazirmatn" pitchFamily="34" charset="-122"/>
-                <a:cs typeface="Vazirmatn" pitchFamily="34" charset="-120"/>
+                <a:latin typeface="Arial" pitchFamily="34" charset="0"/>
+                <a:cs typeface="Arial" pitchFamily="34" charset="178"/>
               </a:rPr>
               <a:t>نشخوار فکری چرا این‌قدر قانع‌کننده است؟</a:t>
             </a:r>
@@ -4098,9 +4076,8 @@
                 <a:solidFill>
                   <a:schemeClr val="accent1"/>
                 </a:solidFill>
-                <a:latin typeface="Vazirmatn" pitchFamily="34" charset="0"/>
-                <a:ea typeface="Vazirmatn" pitchFamily="34" charset="-122"/>
-                <a:cs typeface="Vazirmatn" pitchFamily="34" charset="-120"/>
+                <a:latin typeface="Arial" pitchFamily="34" charset="0"/>
+                <a:cs typeface="Arial" pitchFamily="34" charset="178"/>
               </a:rPr>
               <a:t>۱</a:t>
             </a:r>
@@ -4137,9 +4114,8 @@
                 <a:solidFill>
                   <a:schemeClr val="tx1"/>
                 </a:solidFill>
-                <a:latin typeface="Vazirmatn" pitchFamily="34" charset="0"/>
-                <a:ea typeface="Vazirmatn" pitchFamily="34" charset="-122"/>
-                <a:cs typeface="Vazirmatn" pitchFamily="34" charset="-120"/>
+                <a:latin typeface="Arial" pitchFamily="34" charset="0"/>
+                <a:cs typeface="Arial" pitchFamily="34" charset="178"/>
               </a:rPr>
               <a:t>ابهام</a:t>
             </a:r>
@@ -4179,9 +4155,8 @@
                 <a:solidFill>
                   <a:schemeClr val="accent3"/>
                 </a:solidFill>
-                <a:latin typeface="Vazirmatn" pitchFamily="34" charset="0"/>
-                <a:ea typeface="Vazirmatn" pitchFamily="34" charset="-122"/>
-                <a:cs typeface="Vazirmatn" pitchFamily="34" charset="-120"/>
+                <a:latin typeface="Arial" pitchFamily="34" charset="0"/>
+                <a:cs typeface="Arial" pitchFamily="34" charset="178"/>
               </a:rPr>
               <a:t>«من هنوز نمی‌فهمم چه اتفاقی افتاد.»</a:t>
             </a:r>
@@ -4242,9 +4217,8 @@
                 <a:solidFill>
                   <a:schemeClr val="accent1"/>
                 </a:solidFill>
-                <a:latin typeface="Vazirmatn" pitchFamily="34" charset="0"/>
-                <a:ea typeface="Vazirmatn" pitchFamily="34" charset="-122"/>
-                <a:cs typeface="Vazirmatn" pitchFamily="34" charset="-120"/>
+                <a:latin typeface="Arial" pitchFamily="34" charset="0"/>
+                <a:cs typeface="Arial" pitchFamily="34" charset="178"/>
               </a:rPr>
               <a:t>۲</a:t>
             </a:r>
@@ -4281,9 +4255,8 @@
                 <a:solidFill>
                   <a:schemeClr val="tx1"/>
                 </a:solidFill>
-                <a:latin typeface="Vazirmatn" pitchFamily="34" charset="0"/>
-                <a:ea typeface="Vazirmatn" pitchFamily="34" charset="-122"/>
-                <a:cs typeface="Vazirmatn" pitchFamily="34" charset="-120"/>
+                <a:latin typeface="Arial" pitchFamily="34" charset="0"/>
+                <a:cs typeface="Arial" pitchFamily="34" charset="178"/>
               </a:rPr>
               <a:t>تلاش برای معنا</a:t>
             </a:r>
@@ -4323,9 +4296,8 @@
                 <a:solidFill>
                   <a:schemeClr val="accent3"/>
                 </a:solidFill>
-                <a:latin typeface="Vazirmatn" pitchFamily="34" charset="0"/>
-                <a:ea typeface="Vazirmatn" pitchFamily="34" charset="-122"/>
-                <a:cs typeface="Vazirmatn" pitchFamily="34" charset="-120"/>
+                <a:latin typeface="Arial" pitchFamily="34" charset="0"/>
+                <a:cs typeface="Arial" pitchFamily="34" charset="178"/>
               </a:rPr>
               <a:t>«اگر بیشتر فکر کنم، شاید بفهمم.»</a:t>
             </a:r>
@@ -4386,9 +4358,8 @@
                 <a:solidFill>
                   <a:schemeClr val="accent1"/>
                 </a:solidFill>
-                <a:latin typeface="Vazirmatn" pitchFamily="34" charset="0"/>
-                <a:ea typeface="Vazirmatn" pitchFamily="34" charset="-122"/>
-                <a:cs typeface="Vazirmatn" pitchFamily="34" charset="-120"/>
+                <a:latin typeface="Arial" pitchFamily="34" charset="0"/>
+                <a:cs typeface="Arial" pitchFamily="34" charset="178"/>
               </a:rPr>
               <a:t>۳</a:t>
             </a:r>
@@ -4425,9 +4396,8 @@
                 <a:solidFill>
                   <a:schemeClr val="tx1"/>
                 </a:solidFill>
-                <a:latin typeface="Vazirmatn" pitchFamily="34" charset="0"/>
-                <a:ea typeface="Vazirmatn" pitchFamily="34" charset="-122"/>
-                <a:cs typeface="Vazirmatn" pitchFamily="34" charset="-120"/>
+                <a:latin typeface="Arial" pitchFamily="34" charset="0"/>
+                <a:cs typeface="Arial" pitchFamily="34" charset="178"/>
               </a:rPr>
               <a:t>گیر افتادن</a:t>
             </a:r>
@@ -4467,9 +4437,8 @@
                 <a:solidFill>
                   <a:schemeClr val="accent3"/>
                 </a:solidFill>
-                <a:latin typeface="Vazirmatn" pitchFamily="34" charset="0"/>
-                <a:ea typeface="Vazirmatn" pitchFamily="34" charset="-122"/>
-                <a:cs typeface="Vazirmatn" pitchFamily="34" charset="-120"/>
+                <a:latin typeface="Arial" pitchFamily="34" charset="0"/>
+                <a:cs typeface="Arial" pitchFamily="34" charset="178"/>
               </a:rPr>
               <a:t>فکر تکراری</a:t>
             </a:r>
@@ -4487,9 +4456,8 @@
                 <a:solidFill>
                   <a:schemeClr val="accent3"/>
                 </a:solidFill>
-                <a:latin typeface="Vazirmatn" pitchFamily="34" charset="0"/>
-                <a:ea typeface="Vazirmatn" pitchFamily="34" charset="-122"/>
-                <a:cs typeface="Vazirmatn" pitchFamily="34" charset="-120"/>
+                <a:latin typeface="Arial" pitchFamily="34" charset="0"/>
+                <a:cs typeface="Arial" pitchFamily="34" charset="178"/>
               </a:rPr>
               <a:t>فاصله از تجربه</a:t>
             </a:r>
@@ -4507,9 +4475,8 @@
                 <a:solidFill>
                   <a:schemeClr val="accent3"/>
                 </a:solidFill>
-                <a:latin typeface="Vazirmatn" pitchFamily="34" charset="0"/>
-                <a:ea typeface="Vazirmatn" pitchFamily="34" charset="-122"/>
-                <a:cs typeface="Vazirmatn" pitchFamily="34" charset="-120"/>
+                <a:latin typeface="Arial" pitchFamily="34" charset="0"/>
+                <a:cs typeface="Arial" pitchFamily="34" charset="178"/>
               </a:rPr>
               <a:t>احساس گیرکردن</a:t>
             </a:r>
@@ -4546,9 +4513,8 @@
                 <a:solidFill>
                   <a:schemeClr val="accent5"/>
                 </a:solidFill>
-                <a:latin typeface="Vazirmatn" pitchFamily="34" charset="0"/>
-                <a:ea typeface="Vazirmatn" pitchFamily="34" charset="-122"/>
-                <a:cs typeface="Vazirmatn" pitchFamily="34" charset="-120"/>
+                <a:latin typeface="Arial" pitchFamily="34" charset="0"/>
+                <a:cs typeface="Arial" pitchFamily="34" charset="178"/>
               </a:rPr>
               <a:t>Oblak et al., 2026</a:t>
             </a:r>
@@ -4588,9 +4554,8 @@
                 <a:solidFill>
                   <a:schemeClr val="accent5"/>
                 </a:solidFill>
-                <a:latin typeface="Vazirmatn"/>
-                <a:ea typeface="Vazirmatn"/>
-                <a:cs typeface="Vazirmatn"/>
+                <a:latin typeface="Arial"/>
+                <a:cs typeface="Arial"/>
               </a:defRPr>
             </a:lvl1pPr>
           </a:lstStyle>
@@ -4660,9 +4625,8 @@
                 <a:solidFill>
                   <a:schemeClr val="tx2"/>
                 </a:solidFill>
-                <a:latin typeface="Vazirmatn" pitchFamily="34" charset="0"/>
-                <a:ea typeface="Vazirmatn" pitchFamily="34" charset="-122"/>
-                <a:cs typeface="Vazirmatn" pitchFamily="34" charset="-120"/>
+                <a:latin typeface="Arial" pitchFamily="34" charset="0"/>
+                <a:cs typeface="Arial" pitchFamily="34" charset="178"/>
               </a:rPr>
               <a:t>فکر کردن یا نشخوار؟</a:t>
             </a:r>
@@ -4699,9 +4663,8 @@
                 <a:solidFill>
                   <a:schemeClr val="accent2"/>
                 </a:solidFill>
-                <a:latin typeface="Vazirmatn" pitchFamily="34" charset="0"/>
-                <a:ea typeface="Vazirmatn" pitchFamily="34" charset="-122"/>
-                <a:cs typeface="Vazirmatn" pitchFamily="34" charset="-120"/>
+                <a:latin typeface="Arial" pitchFamily="34" charset="0"/>
+                <a:cs typeface="Arial" pitchFamily="34" charset="178"/>
               </a:rPr>
               <a:t>فکر کردن برای فهمیدن</a:t>
             </a:r>
@@ -4758,9 +4721,8 @@
                 <a:solidFill>
                   <a:schemeClr val="tx1"/>
                 </a:solidFill>
-                <a:latin typeface="Vazirmatn" pitchFamily="34" charset="0"/>
-                <a:ea typeface="Vazirmatn" pitchFamily="34" charset="-122"/>
-                <a:cs typeface="Vazirmatn" pitchFamily="34" charset="-120"/>
+                <a:latin typeface="Arial" pitchFamily="34" charset="0"/>
+                <a:cs typeface="Arial" pitchFamily="34" charset="178"/>
               </a:rPr>
               <a:t>سؤال مشخص</a:t>
             </a:r>
@@ -4817,9 +4779,8 @@
                 <a:solidFill>
                   <a:schemeClr val="tx1"/>
                 </a:solidFill>
-                <a:latin typeface="Vazirmatn" pitchFamily="34" charset="0"/>
-                <a:ea typeface="Vazirmatn" pitchFamily="34" charset="-122"/>
-                <a:cs typeface="Vazirmatn" pitchFamily="34" charset="-120"/>
+                <a:latin typeface="Arial" pitchFamily="34" charset="0"/>
+                <a:cs typeface="Arial" pitchFamily="34" charset="178"/>
               </a:rPr>
               <a:t>اطلاعات تازه</a:t>
             </a:r>
@@ -4876,9 +4837,8 @@
                 <a:solidFill>
                   <a:schemeClr val="tx1"/>
                 </a:solidFill>
-                <a:latin typeface="Vazirmatn" pitchFamily="34" charset="0"/>
-                <a:ea typeface="Vazirmatn" pitchFamily="34" charset="-122"/>
-                <a:cs typeface="Vazirmatn" pitchFamily="34" charset="-120"/>
+                <a:latin typeface="Arial" pitchFamily="34" charset="0"/>
+                <a:cs typeface="Arial" pitchFamily="34" charset="178"/>
               </a:rPr>
               <a:t>تصمیم</a:t>
             </a:r>
@@ -4935,9 +4895,8 @@
                 <a:solidFill>
                   <a:schemeClr val="tx1"/>
                 </a:solidFill>
-                <a:latin typeface="Vazirmatn" pitchFamily="34" charset="0"/>
-                <a:ea typeface="Vazirmatn" pitchFamily="34" charset="-122"/>
-                <a:cs typeface="Vazirmatn" pitchFamily="34" charset="-120"/>
+                <a:latin typeface="Arial" pitchFamily="34" charset="0"/>
+                <a:cs typeface="Arial" pitchFamily="34" charset="178"/>
               </a:rPr>
               <a:t>امکان اقدام</a:t>
             </a:r>
@@ -4997,9 +4956,8 @@
                 <a:solidFill>
                   <a:schemeClr val="accent1"/>
                 </a:solidFill>
-                <a:latin typeface="Vazirmatn" pitchFamily="34" charset="0"/>
-                <a:ea typeface="Vazirmatn" pitchFamily="34" charset="-122"/>
-                <a:cs typeface="Vazirmatn" pitchFamily="34" charset="-120"/>
+                <a:latin typeface="Arial" pitchFamily="34" charset="0"/>
+                <a:cs typeface="Arial" pitchFamily="34" charset="178"/>
               </a:rPr>
               <a:t>نشخوار</a:t>
             </a:r>
@@ -5056,9 +5014,8 @@
                 <a:solidFill>
                   <a:schemeClr val="tx1"/>
                 </a:solidFill>
-                <a:latin typeface="Vazirmatn" pitchFamily="34" charset="0"/>
-                <a:ea typeface="Vazirmatn" pitchFamily="34" charset="-122"/>
-                <a:cs typeface="Vazirmatn" pitchFamily="34" charset="-120"/>
+                <a:latin typeface="Arial" pitchFamily="34" charset="0"/>
+                <a:cs typeface="Arial" pitchFamily="34" charset="178"/>
               </a:rPr>
               <a:t>تکرار همان سؤال</a:t>
             </a:r>
@@ -5115,9 +5072,8 @@
                 <a:solidFill>
                   <a:schemeClr val="tx1"/>
                 </a:solidFill>
-                <a:latin typeface="Vazirmatn" pitchFamily="34" charset="0"/>
-                <a:ea typeface="Vazirmatn" pitchFamily="34" charset="-122"/>
-                <a:cs typeface="Vazirmatn" pitchFamily="34" charset="-120"/>
+                <a:latin typeface="Arial" pitchFamily="34" charset="0"/>
+                <a:cs typeface="Arial" pitchFamily="34" charset="178"/>
               </a:rPr>
               <a:t>بازپخش گذشته</a:t>
             </a:r>
@@ -5174,9 +5130,8 @@
                 <a:solidFill>
                   <a:schemeClr val="tx1"/>
                 </a:solidFill>
-                <a:latin typeface="Vazirmatn" pitchFamily="34" charset="0"/>
-                <a:ea typeface="Vazirmatn" pitchFamily="34" charset="-122"/>
-                <a:cs typeface="Vazirmatn" pitchFamily="34" charset="-120"/>
+                <a:latin typeface="Arial" pitchFamily="34" charset="0"/>
+                <a:cs typeface="Arial" pitchFamily="34" charset="178"/>
               </a:rPr>
               <a:t>برچسب‌زدن به خود</a:t>
             </a:r>
@@ -5233,9 +5188,8 @@
                 <a:solidFill>
                   <a:schemeClr val="tx1"/>
                 </a:solidFill>
-                <a:latin typeface="Vazirmatn" pitchFamily="34" charset="0"/>
-                <a:ea typeface="Vazirmatn" pitchFamily="34" charset="-122"/>
-                <a:cs typeface="Vazirmatn" pitchFamily="34" charset="-120"/>
+                <a:latin typeface="Arial" pitchFamily="34" charset="0"/>
+                <a:cs typeface="Arial" pitchFamily="34" charset="178"/>
               </a:rPr>
               <a:t>احساس گیر افتادن</a:t>
             </a:r>
@@ -5272,9 +5226,8 @@
                 <a:solidFill>
                   <a:schemeClr val="accent5"/>
                 </a:solidFill>
-                <a:latin typeface="Vazirmatn" pitchFamily="34" charset="0"/>
-                <a:ea typeface="Vazirmatn" pitchFamily="34" charset="-122"/>
-                <a:cs typeface="Vazirmatn" pitchFamily="34" charset="-120"/>
+                <a:latin typeface="Arial" pitchFamily="34" charset="0"/>
+                <a:cs typeface="Arial" pitchFamily="34" charset="178"/>
               </a:rPr>
               <a:t>این تمایز یک synthesis آموزشی از یافته‌های پژوهش است.</a:t>
             </a:r>
@@ -5314,9 +5267,8 @@
                 <a:solidFill>
                   <a:schemeClr val="accent5"/>
                 </a:solidFill>
-                <a:latin typeface="Vazirmatn"/>
-                <a:ea typeface="Vazirmatn"/>
-                <a:cs typeface="Vazirmatn"/>
+                <a:latin typeface="Arial"/>
+                <a:cs typeface="Arial"/>
               </a:defRPr>
             </a:lvl1pPr>
           </a:lstStyle>
@@ -5411,9 +5363,8 @@
                 <a:solidFill>
                   <a:schemeClr val="bg1"/>
                 </a:solidFill>
-                <a:latin typeface="Vazirmatn" pitchFamily="34" charset="0"/>
-                <a:ea typeface="Vazirmatn" pitchFamily="34" charset="-122"/>
-                <a:cs typeface="Vazirmatn" pitchFamily="34" charset="-120"/>
+                <a:latin typeface="Arial" pitchFamily="34" charset="0"/>
+                <a:cs typeface="Arial" pitchFamily="34" charset="178"/>
               </a:rPr>
               <a:t>تمرین</a:t>
             </a:r>
@@ -5452,9 +5403,8 @@
                 <a:solidFill>
                   <a:schemeClr val="tx2"/>
                 </a:solidFill>
-                <a:latin typeface="Vazirmatn" pitchFamily="34" charset="0"/>
-                <a:ea typeface="Vazirmatn" pitchFamily="34" charset="-122"/>
-                <a:cs typeface="Vazirmatn" pitchFamily="34" charset="-120"/>
+                <a:latin typeface="Arial" pitchFamily="34" charset="0"/>
+                <a:cs typeface="Arial" pitchFamily="34" charset="178"/>
               </a:rPr>
               <a:t>تمرین ۲ | این فکر واقعاً به کجا می‌رود؟</a:t>
             </a:r>
@@ -5491,9 +5441,8 @@
                 <a:solidFill>
                   <a:schemeClr val="accent2"/>
                 </a:solidFill>
-                <a:latin typeface="Vazirmatn" pitchFamily="34" charset="0"/>
-                <a:ea typeface="Vazirmatn" pitchFamily="34" charset="-122"/>
-                <a:cs typeface="Vazirmatn" pitchFamily="34" charset="-120"/>
+                <a:latin typeface="Arial" pitchFamily="34" charset="0"/>
+                <a:cs typeface="Arial" pitchFamily="34" charset="178"/>
               </a:rPr>
               <a:t>یک فکر تکراری اخیر را بنویسید.</a:t>
             </a:r>
@@ -5555,9 +5504,8 @@
                 <a:solidFill>
                   <a:schemeClr val="accent2"/>
                 </a:solidFill>
-                <a:latin typeface="Vazirmatn" pitchFamily="34" charset="0"/>
-                <a:ea typeface="Vazirmatn" pitchFamily="34" charset="-122"/>
-                <a:cs typeface="Vazirmatn" pitchFamily="34" charset="-120"/>
+                <a:latin typeface="Arial" pitchFamily="34" charset="0"/>
+                <a:cs typeface="Arial" pitchFamily="34" charset="178"/>
               </a:rPr>
               <a:t>۱</a:t>
             </a:r>
@@ -5594,9 +5542,8 @@
                 <a:solidFill>
                   <a:schemeClr val="tx1"/>
                 </a:solidFill>
-                <a:latin typeface="Vazirmatn" pitchFamily="34" charset="0"/>
-                <a:ea typeface="Vazirmatn" pitchFamily="34" charset="-122"/>
-                <a:cs typeface="Vazirmatn" pitchFamily="34" charset="-120"/>
+                <a:latin typeface="Arial" pitchFamily="34" charset="0"/>
+                <a:cs typeface="Arial" pitchFamily="34" charset="178"/>
               </a:rPr>
               <a:t>آیا سؤال جدیدی تولید می‌کند؟</a:t>
             </a:r>
@@ -5658,9 +5605,8 @@
                 <a:solidFill>
                   <a:schemeClr val="accent2"/>
                 </a:solidFill>
-                <a:latin typeface="Vazirmatn" pitchFamily="34" charset="0"/>
-                <a:ea typeface="Vazirmatn" pitchFamily="34" charset="-122"/>
-                <a:cs typeface="Vazirmatn" pitchFamily="34" charset="-120"/>
+                <a:latin typeface="Arial" pitchFamily="34" charset="0"/>
+                <a:cs typeface="Arial" pitchFamily="34" charset="178"/>
               </a:rPr>
               <a:t>۲</a:t>
             </a:r>
@@ -5697,9 +5643,8 @@
                 <a:solidFill>
                   <a:schemeClr val="tx1"/>
                 </a:solidFill>
-                <a:latin typeface="Vazirmatn" pitchFamily="34" charset="0"/>
-                <a:ea typeface="Vazirmatn" pitchFamily="34" charset="-122"/>
-                <a:cs typeface="Vazirmatn" pitchFamily="34" charset="-120"/>
+                <a:latin typeface="Arial" pitchFamily="34" charset="0"/>
+                <a:cs typeface="Arial" pitchFamily="34" charset="178"/>
               </a:rPr>
               <a:t>آیا پاسخ تازه‌ای پیدا می‌کنید؟</a:t>
             </a:r>
@@ -5761,9 +5706,8 @@
                 <a:solidFill>
                   <a:schemeClr val="accent2"/>
                 </a:solidFill>
-                <a:latin typeface="Vazirmatn" pitchFamily="34" charset="0"/>
-                <a:ea typeface="Vazirmatn" pitchFamily="34" charset="-122"/>
-                <a:cs typeface="Vazirmatn" pitchFamily="34" charset="-120"/>
+                <a:latin typeface="Arial" pitchFamily="34" charset="0"/>
+                <a:cs typeface="Arial" pitchFamily="34" charset="178"/>
               </a:rPr>
               <a:t>۳</a:t>
             </a:r>
@@ -5800,9 +5744,8 @@
                 <a:solidFill>
                   <a:schemeClr val="tx1"/>
                 </a:solidFill>
-                <a:latin typeface="Vazirmatn" pitchFamily="34" charset="0"/>
-                <a:ea typeface="Vazirmatn" pitchFamily="34" charset="-122"/>
-                <a:cs typeface="Vazirmatn" pitchFamily="34" charset="-120"/>
+                <a:latin typeface="Arial" pitchFamily="34" charset="0"/>
+                <a:cs typeface="Arial" pitchFamily="34" charset="178"/>
               </a:rPr>
               <a:t>آیا در پایان به یک اقدام مشخص می‌رسید؟</a:t>
             </a:r>
@@ -5866,9 +5809,8 @@
                 <a:solidFill>
                   <a:schemeClr val="accent1"/>
                 </a:solidFill>
-                <a:latin typeface="Vazirmatn" pitchFamily="34" charset="0"/>
-                <a:ea typeface="Vazirmatn" pitchFamily="34" charset="-122"/>
-                <a:cs typeface="Vazirmatn" pitchFamily="34" charset="-120"/>
+                <a:latin typeface="Arial" pitchFamily="34" charset="0"/>
+                <a:cs typeface="Arial" pitchFamily="34" charset="178"/>
               </a:rPr>
               <a:t>اگر نه، آیا ممکن است فکر کردن جای اقدام را گرفته باشد؟</a:t>
             </a:r>
@@ -5905,9 +5847,8 @@
                 <a:solidFill>
                   <a:schemeClr val="accent5"/>
                 </a:solidFill>
-                <a:latin typeface="Vazirmatn" pitchFamily="34" charset="0"/>
-                <a:ea typeface="Vazirmatn" pitchFamily="34" charset="-122"/>
-                <a:cs typeface="Vazirmatn" pitchFamily="34" charset="-120"/>
+                <a:latin typeface="Arial" pitchFamily="34" charset="0"/>
+                <a:cs typeface="Arial" pitchFamily="34" charset="178"/>
               </a:rPr>
               <a:t>این تمرین خودمشاهده‌گری است، نه ابزار تشخیص.</a:t>
             </a:r>
@@ -5947,9 +5888,8 @@
                 <a:solidFill>
                   <a:schemeClr val="accent5"/>
                 </a:solidFill>
-                <a:latin typeface="Vazirmatn"/>
-                <a:ea typeface="Vazirmatn"/>
-                <a:cs typeface="Vazirmatn"/>
+                <a:latin typeface="Arial"/>
+                <a:cs typeface="Arial"/>
               </a:defRPr>
             </a:lvl1pPr>
           </a:lstStyle>
@@ -6019,9 +5959,8 @@
                 <a:solidFill>
                   <a:schemeClr val="tx2"/>
                 </a:solidFill>
-                <a:latin typeface="Vazirmatn" pitchFamily="34" charset="0"/>
-                <a:ea typeface="Vazirmatn" pitchFamily="34" charset="-122"/>
-                <a:cs typeface="Vazirmatn" pitchFamily="34" charset="-120"/>
+                <a:latin typeface="Arial" pitchFamily="34" charset="0"/>
+                <a:cs typeface="Arial" pitchFamily="34" charset="178"/>
               </a:rPr>
               <a:t>وقتی هیجان و نشخوار وارد یک چرخه می‌شوند</a:t>
             </a:r>
@@ -6085,9 +6024,8 @@
                 <a:solidFill>
                   <a:schemeClr val="tx1"/>
                 </a:solidFill>
-                <a:latin typeface="Vazirmatn" pitchFamily="34" charset="0"/>
-                <a:ea typeface="Vazirmatn" pitchFamily="34" charset="-122"/>
-                <a:cs typeface="Vazirmatn" pitchFamily="34" charset="-120"/>
+                <a:latin typeface="Arial" pitchFamily="34" charset="0"/>
+                <a:cs typeface="Arial" pitchFamily="34" charset="178"/>
               </a:rPr>
               <a:t>هیجان شدید</a:t>
             </a:r>
@@ -6175,9 +6113,8 @@
                 <a:solidFill>
                   <a:schemeClr val="tx1"/>
                 </a:solidFill>
-                <a:latin typeface="Vazirmatn" pitchFamily="34" charset="0"/>
-                <a:ea typeface="Vazirmatn" pitchFamily="34" charset="-122"/>
-                <a:cs typeface="Vazirmatn" pitchFamily="34" charset="-120"/>
+                <a:latin typeface="Arial" pitchFamily="34" charset="0"/>
+                <a:cs typeface="Arial" pitchFamily="34" charset="178"/>
               </a:rPr>
               <a:t>تحمل پایین پریشانی</a:t>
             </a:r>
@@ -6265,9 +6202,8 @@
                 <a:solidFill>
                   <a:schemeClr val="tx1"/>
                 </a:solidFill>
-                <a:latin typeface="Vazirmatn" pitchFamily="34" charset="0"/>
-                <a:ea typeface="Vazirmatn" pitchFamily="34" charset="-122"/>
-                <a:cs typeface="Vazirmatn" pitchFamily="34" charset="-120"/>
+                <a:latin typeface="Arial" pitchFamily="34" charset="0"/>
+                <a:cs typeface="Arial" pitchFamily="34" charset="178"/>
               </a:rPr>
               <a:t>فکرهای تکراری</a:t>
             </a:r>
@@ -6355,9 +6291,8 @@
                 <a:solidFill>
                   <a:schemeClr val="tx1"/>
                 </a:solidFill>
-                <a:latin typeface="Vazirmatn" pitchFamily="34" charset="0"/>
-                <a:ea typeface="Vazirmatn" pitchFamily="34" charset="-122"/>
-                <a:cs typeface="Vazirmatn" pitchFamily="34" charset="-120"/>
+                <a:latin typeface="Arial" pitchFamily="34" charset="0"/>
+                <a:cs typeface="Arial" pitchFamily="34" charset="178"/>
               </a:rPr>
               <a:t>هیجان شدیدتر</a:t>
             </a:r>
@@ -6445,9 +6380,8 @@
                 <a:solidFill>
                   <a:schemeClr val="accent1"/>
                 </a:solidFill>
-                <a:latin typeface="Vazirmatn" pitchFamily="34" charset="0"/>
-                <a:ea typeface="Vazirmatn" pitchFamily="34" charset="-122"/>
-                <a:cs typeface="Vazirmatn" pitchFamily="34" charset="-120"/>
+                <a:latin typeface="Arial" pitchFamily="34" charset="0"/>
+                <a:cs typeface="Arial" pitchFamily="34" charset="178"/>
               </a:rPr>
               <a:t>فشار بیشتر</a:t>
             </a:r>
@@ -6557,9 +6491,8 @@
                 <a:solidFill>
                   <a:schemeClr val="accent5"/>
                 </a:solidFill>
-                <a:latin typeface="Vazirmatn" pitchFamily="34" charset="0"/>
-                <a:ea typeface="Vazirmatn" pitchFamily="34" charset="-122"/>
-                <a:cs typeface="Vazirmatn" pitchFamily="34" charset="-120"/>
+                <a:latin typeface="Arial" pitchFamily="34" charset="0"/>
+                <a:cs typeface="Arial" pitchFamily="34" charset="178"/>
               </a:rPr>
               <a:t>یک مطالعه روی ۱۰ نفر دارای NSSI (خودآسیبی بدون قصد خودکشی)؛ برای توضیح «تشدید چرخه»، نه تعمیم به همه.</a:t>
             </a:r>
@@ -6596,9 +6529,8 @@
                 <a:solidFill>
                   <a:schemeClr val="accent5"/>
                 </a:solidFill>
-                <a:latin typeface="Vazirmatn" pitchFamily="34" charset="0"/>
-                <a:ea typeface="Vazirmatn" pitchFamily="34" charset="-122"/>
-                <a:cs typeface="Vazirmatn" pitchFamily="34" charset="-120"/>
+                <a:latin typeface="Arial" pitchFamily="34" charset="0"/>
+                <a:cs typeface="Arial" pitchFamily="34" charset="178"/>
               </a:rPr>
               <a:t>Khan, Rehna &amp; Butt, 2024 | Original Research</a:t>
             </a:r>
@@ -6638,9 +6570,8 @@
                 <a:solidFill>
                   <a:schemeClr val="accent5"/>
                 </a:solidFill>
-                <a:latin typeface="Vazirmatn"/>
-                <a:ea typeface="Vazirmatn"/>
-                <a:cs typeface="Vazirmatn"/>
+                <a:latin typeface="Arial"/>
+                <a:cs typeface="Arial"/>
               </a:defRPr>
             </a:lvl1pPr>
           </a:lstStyle>
@@ -6710,9 +6641,8 @@
                 <a:solidFill>
                   <a:schemeClr val="tx2"/>
                 </a:solidFill>
-                <a:latin typeface="Vazirmatn" pitchFamily="34" charset="0"/>
-                <a:ea typeface="Vazirmatn" pitchFamily="34" charset="-122"/>
-                <a:cs typeface="Vazirmatn" pitchFamily="34" charset="-120"/>
+                <a:latin typeface="Arial" pitchFamily="34" charset="0"/>
+                <a:cs typeface="Arial" pitchFamily="34" charset="178"/>
               </a:rPr>
               <a:t>نقشه کامل چرخه</a:t>
             </a:r>
@@ -6749,9 +6679,8 @@
                 <a:solidFill>
                   <a:schemeClr val="accent1"/>
                 </a:solidFill>
-                <a:latin typeface="Vazirmatn" pitchFamily="34" charset="0"/>
-                <a:ea typeface="Vazirmatn" pitchFamily="34" charset="-122"/>
-                <a:cs typeface="Vazirmatn" pitchFamily="34" charset="-120"/>
+                <a:latin typeface="Arial" pitchFamily="34" charset="0"/>
+                <a:cs typeface="Arial" pitchFamily="34" charset="178"/>
               </a:rPr>
               <a:t>مسیر حمله به خود</a:t>
             </a:r>
@@ -6788,9 +6717,8 @@
                 <a:solidFill>
                   <a:schemeClr val="tx1"/>
                 </a:solidFill>
-                <a:latin typeface="Vazirmatn" pitchFamily="34" charset="0"/>
-                <a:ea typeface="Vazirmatn" pitchFamily="34" charset="-122"/>
-                <a:cs typeface="Vazirmatn" pitchFamily="34" charset="-120"/>
+                <a:latin typeface="Arial" pitchFamily="34" charset="0"/>
+                <a:cs typeface="Arial" pitchFamily="34" charset="178"/>
               </a:rPr>
               <a:t>اتفاق</a:t>
             </a:r>
@@ -6851,9 +6779,8 @@
                 <a:solidFill>
                   <a:schemeClr val="tx1"/>
                 </a:solidFill>
-                <a:latin typeface="Vazirmatn" pitchFamily="34" charset="0"/>
-                <a:ea typeface="Vazirmatn" pitchFamily="34" charset="-122"/>
-                <a:cs typeface="Vazirmatn" pitchFamily="34" charset="-120"/>
+                <a:latin typeface="Arial" pitchFamily="34" charset="0"/>
+                <a:cs typeface="Arial" pitchFamily="34" charset="178"/>
               </a:rPr>
               <a:t>احساس</a:t>
             </a:r>
@@ -6914,9 +6841,8 @@
                 <a:solidFill>
                   <a:schemeClr val="tx1"/>
                 </a:solidFill>
-                <a:latin typeface="Vazirmatn" pitchFamily="34" charset="0"/>
-                <a:ea typeface="Vazirmatn" pitchFamily="34" charset="-122"/>
-                <a:cs typeface="Vazirmatn" pitchFamily="34" charset="-120"/>
+                <a:latin typeface="Arial" pitchFamily="34" charset="0"/>
+                <a:cs typeface="Arial" pitchFamily="34" charset="178"/>
               </a:rPr>
               <a:t>«مشکل منم»</a:t>
             </a:r>
@@ -6977,9 +6903,8 @@
                 <a:solidFill>
                   <a:schemeClr val="tx1"/>
                 </a:solidFill>
-                <a:latin typeface="Vazirmatn" pitchFamily="34" charset="0"/>
-                <a:ea typeface="Vazirmatn" pitchFamily="34" charset="-122"/>
-                <a:cs typeface="Vazirmatn" pitchFamily="34" charset="-120"/>
+                <a:latin typeface="Arial" pitchFamily="34" charset="0"/>
+                <a:cs typeface="Arial" pitchFamily="34" charset="178"/>
               </a:rPr>
               <a:t>خودسرزنشی</a:t>
             </a:r>
@@ -7040,9 +6965,8 @@
                 <a:solidFill>
                   <a:schemeClr val="tx1"/>
                 </a:solidFill>
-                <a:latin typeface="Vazirmatn" pitchFamily="34" charset="0"/>
-                <a:ea typeface="Vazirmatn" pitchFamily="34" charset="-122"/>
-                <a:cs typeface="Vazirmatn" pitchFamily="34" charset="-120"/>
+                <a:latin typeface="Arial" pitchFamily="34" charset="0"/>
+                <a:cs typeface="Arial" pitchFamily="34" charset="178"/>
               </a:rPr>
               <a:t>نشخوار</a:t>
             </a:r>
@@ -7103,9 +7027,8 @@
                 <a:solidFill>
                   <a:schemeClr val="tx1"/>
                 </a:solidFill>
-                <a:latin typeface="Vazirmatn" pitchFamily="34" charset="0"/>
-                <a:ea typeface="Vazirmatn" pitchFamily="34" charset="-122"/>
-                <a:cs typeface="Vazirmatn" pitchFamily="34" charset="-120"/>
+                <a:latin typeface="Arial" pitchFamily="34" charset="0"/>
+                <a:cs typeface="Arial" pitchFamily="34" charset="178"/>
               </a:rPr>
               <a:t>حمله به خود</a:t>
             </a:r>
@@ -7193,9 +7116,8 @@
                 <a:solidFill>
                   <a:schemeClr val="bg1"/>
                 </a:solidFill>
-                <a:latin typeface="Vazirmatn" pitchFamily="34" charset="0"/>
-                <a:ea typeface="Vazirmatn" pitchFamily="34" charset="-122"/>
-                <a:cs typeface="Vazirmatn" pitchFamily="34" charset="-120"/>
+                <a:latin typeface="Arial" pitchFamily="34" charset="0"/>
+                <a:cs typeface="Arial" pitchFamily="34" charset="178"/>
               </a:rPr>
               <a:t>پریشانی</a:t>
             </a:r>
@@ -7255,9 +7177,8 @@
                 <a:solidFill>
                   <a:schemeClr val="accent2"/>
                 </a:solidFill>
-                <a:latin typeface="Vazirmatn" pitchFamily="34" charset="0"/>
-                <a:ea typeface="Vazirmatn" pitchFamily="34" charset="-122"/>
-                <a:cs typeface="Vazirmatn" pitchFamily="34" charset="-120"/>
+                <a:latin typeface="Arial" pitchFamily="34" charset="0"/>
+                <a:cs typeface="Arial" pitchFamily="34" charset="178"/>
               </a:rPr>
               <a:t>مسیر پردازش و اقدام</a:t>
             </a:r>
@@ -7294,9 +7215,8 @@
                 <a:solidFill>
                   <a:schemeClr val="tx1"/>
                 </a:solidFill>
-                <a:latin typeface="Vazirmatn" pitchFamily="34" charset="0"/>
-                <a:ea typeface="Vazirmatn" pitchFamily="34" charset="-122"/>
-                <a:cs typeface="Vazirmatn" pitchFamily="34" charset="-120"/>
+                <a:latin typeface="Arial" pitchFamily="34" charset="0"/>
+                <a:cs typeface="Arial" pitchFamily="34" charset="178"/>
               </a:rPr>
               <a:t>اتفاق</a:t>
             </a:r>
@@ -7357,9 +7277,8 @@
                 <a:solidFill>
                   <a:schemeClr val="tx1"/>
                 </a:solidFill>
-                <a:latin typeface="Vazirmatn" pitchFamily="34" charset="0"/>
-                <a:ea typeface="Vazirmatn" pitchFamily="34" charset="-122"/>
-                <a:cs typeface="Vazirmatn" pitchFamily="34" charset="-120"/>
+                <a:latin typeface="Arial" pitchFamily="34" charset="0"/>
+                <a:cs typeface="Arial" pitchFamily="34" charset="178"/>
               </a:rPr>
               <a:t>احساس</a:t>
             </a:r>
@@ -7420,9 +7339,8 @@
                 <a:solidFill>
                   <a:schemeClr val="tx1"/>
                 </a:solidFill>
-                <a:latin typeface="Vazirmatn" pitchFamily="34" charset="0"/>
-                <a:ea typeface="Vazirmatn" pitchFamily="34" charset="-122"/>
-                <a:cs typeface="Vazirmatn" pitchFamily="34" charset="-120"/>
+                <a:latin typeface="Arial" pitchFamily="34" charset="0"/>
+                <a:cs typeface="Arial" pitchFamily="34" charset="178"/>
               </a:rPr>
               <a:t>نیاز</a:t>
             </a:r>
@@ -7483,9 +7401,8 @@
                 <a:solidFill>
                   <a:schemeClr val="tx1"/>
                 </a:solidFill>
-                <a:latin typeface="Vazirmatn" pitchFamily="34" charset="0"/>
-                <a:ea typeface="Vazirmatn" pitchFamily="34" charset="-122"/>
-                <a:cs typeface="Vazirmatn" pitchFamily="34" charset="-120"/>
+                <a:latin typeface="Arial" pitchFamily="34" charset="0"/>
+                <a:cs typeface="Arial" pitchFamily="34" charset="178"/>
               </a:rPr>
               <a:t>خودحمایتی</a:t>
             </a:r>
@@ -7546,9 +7463,8 @@
                 <a:solidFill>
                   <a:schemeClr val="tx1"/>
                 </a:solidFill>
-                <a:latin typeface="Vazirmatn" pitchFamily="34" charset="0"/>
-                <a:ea typeface="Vazirmatn" pitchFamily="34" charset="-122"/>
-                <a:cs typeface="Vazirmatn" pitchFamily="34" charset="-120"/>
+                <a:latin typeface="Arial" pitchFamily="34" charset="0"/>
+                <a:cs typeface="Arial" pitchFamily="34" charset="178"/>
               </a:rPr>
               <a:t>خشم قاطعانه / محافظتی</a:t>
             </a:r>
@@ -7609,9 +7525,8 @@
                 <a:solidFill>
                   <a:schemeClr val="tx1"/>
                 </a:solidFill>
-                <a:latin typeface="Vazirmatn" pitchFamily="34" charset="0"/>
-                <a:ea typeface="Vazirmatn" pitchFamily="34" charset="-122"/>
-                <a:cs typeface="Vazirmatn" pitchFamily="34" charset="-120"/>
+                <a:latin typeface="Arial" pitchFamily="34" charset="0"/>
+                <a:cs typeface="Arial" pitchFamily="34" charset="178"/>
               </a:rPr>
               <a:t>مرز</a:t>
             </a:r>
@@ -7699,9 +7614,8 @@
                 <a:solidFill>
                   <a:schemeClr val="bg1"/>
                 </a:solidFill>
-                <a:latin typeface="Vazirmatn" pitchFamily="34" charset="0"/>
-                <a:ea typeface="Vazirmatn" pitchFamily="34" charset="-122"/>
-                <a:cs typeface="Vazirmatn" pitchFamily="34" charset="-120"/>
+                <a:latin typeface="Arial" pitchFamily="34" charset="0"/>
+                <a:cs typeface="Arial" pitchFamily="34" charset="178"/>
               </a:rPr>
               <a:t>اقدام</a:t>
             </a:r>
@@ -7758,9 +7672,8 @@
                 <a:solidFill>
                   <a:schemeClr val="accent5"/>
                 </a:solidFill>
-                <a:latin typeface="Vazirmatn" pitchFamily="34" charset="0"/>
-                <a:ea typeface="Vazirmatn" pitchFamily="34" charset="-122"/>
-                <a:cs typeface="Vazirmatn" pitchFamily="34" charset="-120"/>
+                <a:latin typeface="Arial" pitchFamily="34" charset="0"/>
+                <a:cs typeface="Arial" pitchFamily="34" charset="178"/>
               </a:rPr>
               <a:t>این نقشه، ترکیب آموزشی سه پژوهش است؛ نه یک مدل واحد منتشرشده.</a:t>
             </a:r>
@@ -7800,9 +7713,8 @@
                 <a:solidFill>
                   <a:schemeClr val="accent5"/>
                 </a:solidFill>
-                <a:latin typeface="Vazirmatn"/>
-                <a:ea typeface="Vazirmatn"/>
-                <a:cs typeface="Vazirmatn"/>
+                <a:latin typeface="Arial"/>
+                <a:cs typeface="Arial"/>
               </a:defRPr>
             </a:lvl1pPr>
           </a:lstStyle>
@@ -7872,9 +7784,8 @@
                 <a:solidFill>
                   <a:schemeClr val="tx2"/>
                 </a:solidFill>
-                <a:latin typeface="Vazirmatn" pitchFamily="34" charset="0"/>
-                <a:ea typeface="Vazirmatn" pitchFamily="34" charset="-122"/>
-                <a:cs typeface="Vazirmatn" pitchFamily="34" charset="-120"/>
+                <a:latin typeface="Arial" pitchFamily="34" charset="0"/>
+                <a:cs typeface="Arial" pitchFamily="34" charset="178"/>
               </a:rPr>
               <a:t>مسیر خروج از چرخه</a:t>
             </a:r>
@@ -7911,9 +7822,8 @@
                 <a:solidFill>
                   <a:schemeClr val="accent1"/>
                 </a:solidFill>
-                <a:latin typeface="Vazirmatn" pitchFamily="34" charset="0"/>
-                <a:ea typeface="Vazirmatn" pitchFamily="34" charset="-122"/>
-                <a:cs typeface="Vazirmatn" pitchFamily="34" charset="-120"/>
+                <a:latin typeface="Arial" pitchFamily="34" charset="0"/>
+                <a:cs typeface="Arial" pitchFamily="34" charset="178"/>
               </a:rPr>
               <a:t>۱</a:t>
             </a:r>
@@ -7950,9 +7860,8 @@
                 <a:solidFill>
                   <a:schemeClr val="tx1"/>
                 </a:solidFill>
-                <a:latin typeface="Vazirmatn" pitchFamily="34" charset="0"/>
-                <a:ea typeface="Vazirmatn" pitchFamily="34" charset="-122"/>
-                <a:cs typeface="Vazirmatn" pitchFamily="34" charset="-120"/>
+                <a:latin typeface="Arial" pitchFamily="34" charset="0"/>
+                <a:cs typeface="Arial" pitchFamily="34" charset="178"/>
               </a:rPr>
               <a:t>منتقد را ببین</a:t>
             </a:r>
@@ -7989,9 +7898,8 @@
                 <a:solidFill>
                   <a:schemeClr val="accent5"/>
                 </a:solidFill>
-                <a:latin typeface="Vazirmatn" pitchFamily="34" charset="0"/>
-                <a:ea typeface="Vazirmatn" pitchFamily="34" charset="-122"/>
-                <a:cs typeface="Vazirmatn" pitchFamily="34" charset="-120"/>
+                <a:latin typeface="Arial" pitchFamily="34" charset="0"/>
+                <a:cs typeface="Arial" pitchFamily="34" charset="178"/>
               </a:rPr>
               <a:t>«الان چه صدایی فعال شده؟»</a:t>
             </a:r>
@@ -8051,9 +7959,8 @@
                 <a:solidFill>
                   <a:schemeClr val="accent1"/>
                 </a:solidFill>
-                <a:latin typeface="Vazirmatn" pitchFamily="34" charset="0"/>
-                <a:ea typeface="Vazirmatn" pitchFamily="34" charset="-122"/>
-                <a:cs typeface="Vazirmatn" pitchFamily="34" charset="-120"/>
+                <a:latin typeface="Arial" pitchFamily="34" charset="0"/>
+                <a:cs typeface="Arial" pitchFamily="34" charset="178"/>
               </a:rPr>
               <a:t>۲</a:t>
             </a:r>
@@ -8090,9 +7997,8 @@
                 <a:solidFill>
                   <a:schemeClr val="tx1"/>
                 </a:solidFill>
-                <a:latin typeface="Vazirmatn" pitchFamily="34" charset="0"/>
-                <a:ea typeface="Vazirmatn" pitchFamily="34" charset="-122"/>
-                <a:cs typeface="Vazirmatn" pitchFamily="34" charset="-120"/>
+                <a:latin typeface="Arial" pitchFamily="34" charset="0"/>
+                <a:cs typeface="Arial" pitchFamily="34" charset="178"/>
               </a:rPr>
               <a:t>احساس را نام ببر</a:t>
             </a:r>
@@ -8129,9 +8035,8 @@
                 <a:solidFill>
                   <a:schemeClr val="accent5"/>
                 </a:solidFill>
-                <a:latin typeface="Vazirmatn" pitchFamily="34" charset="0"/>
-                <a:ea typeface="Vazirmatn" pitchFamily="34" charset="-122"/>
-                <a:cs typeface="Vazirmatn" pitchFamily="34" charset="-120"/>
+                <a:latin typeface="Arial" pitchFamily="34" charset="0"/>
+                <a:cs typeface="Arial" pitchFamily="34" charset="178"/>
               </a:rPr>
               <a:t>«واقعاً چه احساسی دارم؟»</a:t>
             </a:r>
@@ -8191,9 +8096,8 @@
                 <a:solidFill>
                   <a:schemeClr val="accent1"/>
                 </a:solidFill>
-                <a:latin typeface="Vazirmatn" pitchFamily="34" charset="0"/>
-                <a:ea typeface="Vazirmatn" pitchFamily="34" charset="-122"/>
-                <a:cs typeface="Vazirmatn" pitchFamily="34" charset="-120"/>
+                <a:latin typeface="Arial" pitchFamily="34" charset="0"/>
+                <a:cs typeface="Arial" pitchFamily="34" charset="178"/>
               </a:rPr>
               <a:t>۳</a:t>
             </a:r>
@@ -8230,9 +8134,8 @@
                 <a:solidFill>
                   <a:schemeClr val="tx1"/>
                 </a:solidFill>
-                <a:latin typeface="Vazirmatn" pitchFamily="34" charset="0"/>
-                <a:ea typeface="Vazirmatn" pitchFamily="34" charset="-122"/>
-                <a:cs typeface="Vazirmatn" pitchFamily="34" charset="-120"/>
+                <a:latin typeface="Arial" pitchFamily="34" charset="0"/>
+                <a:cs typeface="Arial" pitchFamily="34" charset="178"/>
               </a:rPr>
               <a:t>نیاز را پیدا کن</a:t>
             </a:r>
@@ -8269,9 +8172,8 @@
                 <a:solidFill>
                   <a:schemeClr val="accent5"/>
                 </a:solidFill>
-                <a:latin typeface="Vazirmatn" pitchFamily="34" charset="0"/>
-                <a:ea typeface="Vazirmatn" pitchFamily="34" charset="-122"/>
-                <a:cs typeface="Vazirmatn" pitchFamily="34" charset="-120"/>
+                <a:latin typeface="Arial" pitchFamily="34" charset="0"/>
+                <a:cs typeface="Arial" pitchFamily="34" charset="178"/>
               </a:rPr>
               <a:t>«چه چیزی برایم مهم بوده؟»</a:t>
             </a:r>
@@ -8331,9 +8233,8 @@
                 <a:solidFill>
                   <a:schemeClr val="accent1"/>
                 </a:solidFill>
-                <a:latin typeface="Vazirmatn" pitchFamily="34" charset="0"/>
-                <a:ea typeface="Vazirmatn" pitchFamily="34" charset="-122"/>
-                <a:cs typeface="Vazirmatn" pitchFamily="34" charset="-120"/>
+                <a:latin typeface="Arial" pitchFamily="34" charset="0"/>
+                <a:cs typeface="Arial" pitchFamily="34" charset="178"/>
               </a:rPr>
               <a:t>۴</a:t>
             </a:r>
@@ -8370,9 +8271,8 @@
                 <a:solidFill>
                   <a:schemeClr val="tx1"/>
                 </a:solidFill>
-                <a:latin typeface="Vazirmatn" pitchFamily="34" charset="0"/>
-                <a:ea typeface="Vazirmatn" pitchFamily="34" charset="-122"/>
-                <a:cs typeface="Vazirmatn" pitchFamily="34" charset="-120"/>
+                <a:latin typeface="Arial" pitchFamily="34" charset="0"/>
+                <a:cs typeface="Arial" pitchFamily="34" charset="178"/>
               </a:rPr>
               <a:t>از خودت محافظت کن</a:t>
             </a:r>
@@ -8409,9 +8309,8 @@
                 <a:solidFill>
                   <a:schemeClr val="accent5"/>
                 </a:solidFill>
-                <a:latin typeface="Vazirmatn" pitchFamily="34" charset="0"/>
-                <a:ea typeface="Vazirmatn" pitchFamily="34" charset="-122"/>
-                <a:cs typeface="Vazirmatn" pitchFamily="34" charset="-120"/>
+                <a:latin typeface="Arial" pitchFamily="34" charset="0"/>
+                <a:cs typeface="Arial" pitchFamily="34" charset="178"/>
               </a:rPr>
               <a:t>«چطور علیه خودم رفتار نکنم؟»</a:t>
             </a:r>
@@ -8475,9 +8374,8 @@
                 <a:solidFill>
                   <a:schemeClr val="accent2"/>
                 </a:solidFill>
-                <a:latin typeface="Vazirmatn" pitchFamily="34" charset="0"/>
-                <a:ea typeface="Vazirmatn" pitchFamily="34" charset="-122"/>
-                <a:cs typeface="Vazirmatn" pitchFamily="34" charset="-120"/>
+                <a:latin typeface="Arial" pitchFamily="34" charset="0"/>
+                <a:cs typeface="Arial" pitchFamily="34" charset="178"/>
               </a:rPr>
               <a:t>۵</a:t>
             </a:r>
@@ -8514,9 +8412,8 @@
                 <a:solidFill>
                   <a:schemeClr val="accent3"/>
                 </a:solidFill>
-                <a:latin typeface="Vazirmatn" pitchFamily="34" charset="0"/>
-                <a:ea typeface="Vazirmatn" pitchFamily="34" charset="-122"/>
-                <a:cs typeface="Vazirmatn" pitchFamily="34" charset="-120"/>
+                <a:latin typeface="Arial" pitchFamily="34" charset="0"/>
+                <a:cs typeface="Arial" pitchFamily="34" charset="178"/>
               </a:rPr>
               <a:t>به اقدام برس</a:t>
             </a:r>
@@ -8553,9 +8450,8 @@
                 <a:solidFill>
                   <a:schemeClr val="accent5"/>
                 </a:solidFill>
-                <a:latin typeface="Vazirmatn" pitchFamily="34" charset="0"/>
-                <a:ea typeface="Vazirmatn" pitchFamily="34" charset="-122"/>
-                <a:cs typeface="Vazirmatn" pitchFamily="34" charset="-120"/>
+                <a:latin typeface="Arial" pitchFamily="34" charset="0"/>
+                <a:cs typeface="Arial" pitchFamily="34" charset="178"/>
               </a:rPr>
               <a:t>«چه مرز یا خواسته‌ای دارم؟»</a:t>
             </a:r>
@@ -8595,9 +8491,8 @@
                 <a:solidFill>
                   <a:schemeClr val="accent5"/>
                 </a:solidFill>
-                <a:latin typeface="Vazirmatn"/>
-                <a:ea typeface="Vazirmatn"/>
-                <a:cs typeface="Vazirmatn"/>
+                <a:latin typeface="Arial"/>
+                <a:cs typeface="Arial"/>
               </a:defRPr>
             </a:lvl1pPr>
           </a:lstStyle>
@@ -8667,9 +8562,8 @@
                 <a:solidFill>
                   <a:schemeClr val="tx2"/>
                 </a:solidFill>
-                <a:latin typeface="Vazirmatn" pitchFamily="34" charset="0"/>
-                <a:ea typeface="Vazirmatn" pitchFamily="34" charset="-122"/>
-                <a:cs typeface="Vazirmatn" pitchFamily="34" charset="-120"/>
+                <a:latin typeface="Arial" pitchFamily="34" charset="0"/>
+                <a:cs typeface="Arial" pitchFamily="34" charset="178"/>
               </a:rPr>
               <a:t>یک فرمول ساده برای بردن با خودتان</a:t>
             </a:r>
@@ -8702,17 +8596,16 @@
               <a:buNone/>
             </a:pPr>
             <a:r>
-              <a:rPr lang="fa-IR" altLang="en-US" sz="4800" b="1" dirty="0">
+              <a:rPr lang="fa-IR" altLang="en-US" sz="4400" b="1" dirty="0">
                 <a:solidFill>
                   <a:schemeClr val="accent2"/>
                 </a:solidFill>
-                <a:latin typeface="Vazirmatn" pitchFamily="34" charset="0"/>
-                <a:ea typeface="Vazirmatn" pitchFamily="34" charset="-122"/>
-                <a:cs typeface="Vazirmatn" pitchFamily="34" charset="-120"/>
+                <a:latin typeface="Arial" pitchFamily="34" charset="0"/>
+                <a:cs typeface="Arial" pitchFamily="34" charset="178"/>
               </a:rPr>
               <a:t>احساس</a:t>
             </a:r>
-            <a:endParaRPr lang="fa-IR" sz="4800" dirty="0"/>
+            <a:endParaRPr lang="fa-IR" sz="4400" dirty="0"/>
           </a:p>
         </p:txBody>
       </p:sp>
@@ -8765,17 +8658,16 @@
               <a:buNone/>
             </a:pPr>
             <a:r>
-              <a:rPr lang="fa-IR" altLang="en-US" sz="4800" b="1" dirty="0">
+              <a:rPr lang="fa-IR" altLang="en-US" sz="4400" b="1" dirty="0">
                 <a:solidFill>
                   <a:schemeClr val="accent2"/>
                 </a:solidFill>
-                <a:latin typeface="Vazirmatn" pitchFamily="34" charset="0"/>
-                <a:ea typeface="Vazirmatn" pitchFamily="34" charset="-122"/>
-                <a:cs typeface="Vazirmatn" pitchFamily="34" charset="-120"/>
+                <a:latin typeface="Arial" pitchFamily="34" charset="0"/>
+                <a:cs typeface="Arial" pitchFamily="34" charset="178"/>
               </a:rPr>
               <a:t>نیاز</a:t>
             </a:r>
-            <a:endParaRPr lang="fa-IR" sz="4800" dirty="0"/>
+            <a:endParaRPr lang="fa-IR" sz="4400" dirty="0"/>
           </a:p>
         </p:txBody>
       </p:sp>
@@ -8828,17 +8720,16 @@
               <a:buNone/>
             </a:pPr>
             <a:r>
-              <a:rPr lang="fa-IR" altLang="en-US" sz="4800" b="1" dirty="0">
+              <a:rPr lang="fa-IR" altLang="en-US" sz="4400" b="1" dirty="0">
                 <a:solidFill>
                   <a:schemeClr val="accent2"/>
                 </a:solidFill>
-                <a:latin typeface="Vazirmatn" pitchFamily="34" charset="0"/>
-                <a:ea typeface="Vazirmatn" pitchFamily="34" charset="-122"/>
-                <a:cs typeface="Vazirmatn" pitchFamily="34" charset="-120"/>
+                <a:latin typeface="Arial" pitchFamily="34" charset="0"/>
+                <a:cs typeface="Arial" pitchFamily="34" charset="178"/>
               </a:rPr>
               <a:t>مرز</a:t>
             </a:r>
-            <a:endParaRPr lang="fa-IR" sz="4800" dirty="0"/>
+            <a:endParaRPr lang="fa-IR" sz="4400" dirty="0"/>
           </a:p>
         </p:txBody>
       </p:sp>
@@ -8891,17 +8782,16 @@
               <a:buNone/>
             </a:pPr>
             <a:r>
-              <a:rPr lang="fa-IR" altLang="en-US" sz="4800" b="1" dirty="0">
+              <a:rPr lang="fa-IR" altLang="en-US" sz="4400" b="1" dirty="0">
                 <a:solidFill>
                   <a:schemeClr val="accent3"/>
                 </a:solidFill>
-                <a:latin typeface="Vazirmatn" pitchFamily="34" charset="0"/>
-                <a:ea typeface="Vazirmatn" pitchFamily="34" charset="-122"/>
-                <a:cs typeface="Vazirmatn" pitchFamily="34" charset="-120"/>
+                <a:latin typeface="Arial" pitchFamily="34" charset="0"/>
+                <a:cs typeface="Arial" pitchFamily="34" charset="178"/>
               </a:rPr>
               <a:t>اقدام</a:t>
             </a:r>
-            <a:endParaRPr lang="fa-IR" sz="4800" dirty="0"/>
+            <a:endParaRPr lang="fa-IR" sz="4400" dirty="0"/>
           </a:p>
         </p:txBody>
       </p:sp>
@@ -8934,9 +8824,8 @@
                 <a:solidFill>
                   <a:schemeClr val="accent6"/>
                 </a:solidFill>
-                <a:latin typeface="Vazirmatn" pitchFamily="34" charset="0"/>
-                <a:ea typeface="Vazirmatn" pitchFamily="34" charset="-122"/>
-                <a:cs typeface="Vazirmatn" pitchFamily="34" charset="-120"/>
+                <a:latin typeface="Arial" pitchFamily="34" charset="0"/>
+                <a:cs typeface="Arial" pitchFamily="34" charset="178"/>
               </a:rPr>
               <a:t>نه:</a:t>
             </a:r>
@@ -8973,9 +8862,8 @@
                 <a:solidFill>
                   <a:schemeClr val="accent5"/>
                 </a:solidFill>
-                <a:latin typeface="Vazirmatn" pitchFamily="34" charset="0"/>
-                <a:ea typeface="Vazirmatn" pitchFamily="34" charset="-122"/>
-                <a:cs typeface="Vazirmatn" pitchFamily="34" charset="-120"/>
+                <a:latin typeface="Arial" pitchFamily="34" charset="0"/>
+                <a:cs typeface="Arial" pitchFamily="34" charset="178"/>
               </a:rPr>
               <a:t>احساس</a:t>
             </a:r>
@@ -9036,9 +8924,8 @@
                 <a:solidFill>
                   <a:schemeClr val="accent5"/>
                 </a:solidFill>
-                <a:latin typeface="Vazirmatn" pitchFamily="34" charset="0"/>
-                <a:ea typeface="Vazirmatn" pitchFamily="34" charset="-122"/>
-                <a:cs typeface="Vazirmatn" pitchFamily="34" charset="-120"/>
+                <a:latin typeface="Arial" pitchFamily="34" charset="0"/>
+                <a:cs typeface="Arial" pitchFamily="34" charset="178"/>
               </a:rPr>
               <a:t>قضاوت خود</a:t>
             </a:r>
@@ -9099,9 +8986,8 @@
                 <a:solidFill>
                   <a:schemeClr val="accent5"/>
                 </a:solidFill>
-                <a:latin typeface="Vazirmatn" pitchFamily="34" charset="0"/>
-                <a:ea typeface="Vazirmatn" pitchFamily="34" charset="-122"/>
-                <a:cs typeface="Vazirmatn" pitchFamily="34" charset="-120"/>
+                <a:latin typeface="Arial" pitchFamily="34" charset="0"/>
+                <a:cs typeface="Arial" pitchFamily="34" charset="178"/>
               </a:rPr>
               <a:t>نشخوار</a:t>
             </a:r>
@@ -9162,9 +9048,8 @@
                 <a:solidFill>
                   <a:schemeClr val="accent5"/>
                 </a:solidFill>
-                <a:latin typeface="Vazirmatn" pitchFamily="34" charset="0"/>
-                <a:ea typeface="Vazirmatn" pitchFamily="34" charset="-122"/>
-                <a:cs typeface="Vazirmatn" pitchFamily="34" charset="-120"/>
+                <a:latin typeface="Arial" pitchFamily="34" charset="0"/>
+                <a:cs typeface="Arial" pitchFamily="34" charset="178"/>
               </a:rPr>
               <a:t>حمله به خود</a:t>
             </a:r>
@@ -9204,9 +9089,8 @@
                 <a:solidFill>
                   <a:schemeClr val="accent5"/>
                 </a:solidFill>
-                <a:latin typeface="Vazirmatn"/>
-                <a:ea typeface="Vazirmatn"/>
-                <a:cs typeface="Vazirmatn"/>
+                <a:latin typeface="Arial"/>
+                <a:cs typeface="Arial"/>
               </a:defRPr>
             </a:lvl1pPr>
           </a:lstStyle>
@@ -9301,9 +9185,8 @@
                 <a:solidFill>
                   <a:schemeClr val="bg1"/>
                 </a:solidFill>
-                <a:latin typeface="Vazirmatn" pitchFamily="34" charset="0"/>
-                <a:ea typeface="Vazirmatn" pitchFamily="34" charset="-122"/>
-                <a:cs typeface="Vazirmatn" pitchFamily="34" charset="-120"/>
+                <a:latin typeface="Arial" pitchFamily="34" charset="0"/>
+                <a:cs typeface="Arial" pitchFamily="34" charset="178"/>
               </a:rPr>
               <a:t>تمرین</a:t>
             </a:r>
@@ -9342,9 +9225,8 @@
                 <a:solidFill>
                   <a:schemeClr val="tx2"/>
                 </a:solidFill>
-                <a:latin typeface="Vazirmatn" pitchFamily="34" charset="0"/>
-                <a:ea typeface="Vazirmatn" pitchFamily="34" charset="-122"/>
-                <a:cs typeface="Vazirmatn" pitchFamily="34" charset="-120"/>
+                <a:latin typeface="Arial" pitchFamily="34" charset="0"/>
+                <a:cs typeface="Arial" pitchFamily="34" charset="178"/>
               </a:rPr>
               <a:t>تمرین نهایی | نقشه چرخه شخصی من</a:t>
             </a:r>
@@ -9408,9 +9290,8 @@
                 <a:solidFill>
                   <a:schemeClr val="accent1"/>
                 </a:solidFill>
-                <a:latin typeface="Vazirmatn" pitchFamily="34" charset="0"/>
-                <a:ea typeface="Vazirmatn" pitchFamily="34" charset="-122"/>
-                <a:cs typeface="Vazirmatn" pitchFamily="34" charset="-120"/>
+                <a:latin typeface="Arial" pitchFamily="34" charset="0"/>
+                <a:cs typeface="Arial" pitchFamily="34" charset="178"/>
               </a:rPr>
               <a:t>اتفاق</a:t>
             </a:r>
@@ -9450,9 +9331,8 @@
                 <a:solidFill>
                   <a:schemeClr val="accent5"/>
                 </a:solidFill>
-                <a:latin typeface="Vazirmatn" pitchFamily="34" charset="0"/>
-                <a:ea typeface="Vazirmatn" pitchFamily="34" charset="-122"/>
-                <a:cs typeface="Vazirmatn" pitchFamily="34" charset="-120"/>
+                <a:latin typeface="Arial" pitchFamily="34" charset="0"/>
+                <a:cs typeface="Arial" pitchFamily="34" charset="178"/>
               </a:rPr>
               <a:t>چه شد؟</a:t>
             </a:r>
@@ -9516,9 +9396,8 @@
                 <a:solidFill>
                   <a:schemeClr val="accent1"/>
                 </a:solidFill>
-                <a:latin typeface="Vazirmatn" pitchFamily="34" charset="0"/>
-                <a:ea typeface="Vazirmatn" pitchFamily="34" charset="-122"/>
-                <a:cs typeface="Vazirmatn" pitchFamily="34" charset="-120"/>
+                <a:latin typeface="Arial" pitchFamily="34" charset="0"/>
+                <a:cs typeface="Arial" pitchFamily="34" charset="178"/>
               </a:rPr>
               <a:t>احساس</a:t>
             </a:r>
@@ -9558,9 +9437,8 @@
                 <a:solidFill>
                   <a:schemeClr val="accent5"/>
                 </a:solidFill>
-                <a:latin typeface="Vazirmatn" pitchFamily="34" charset="0"/>
-                <a:ea typeface="Vazirmatn" pitchFamily="34" charset="-122"/>
-                <a:cs typeface="Vazirmatn" pitchFamily="34" charset="-120"/>
+                <a:latin typeface="Arial" pitchFamily="34" charset="0"/>
+                <a:cs typeface="Arial" pitchFamily="34" charset="178"/>
               </a:rPr>
               <a:t>چه احساسی داشتم؟</a:t>
             </a:r>
@@ -9624,9 +9502,8 @@
                 <a:solidFill>
                   <a:schemeClr val="accent1"/>
                 </a:solidFill>
-                <a:latin typeface="Vazirmatn" pitchFamily="34" charset="0"/>
-                <a:ea typeface="Vazirmatn" pitchFamily="34" charset="-122"/>
-                <a:cs typeface="Vazirmatn" pitchFamily="34" charset="-120"/>
+                <a:latin typeface="Arial" pitchFamily="34" charset="0"/>
+                <a:cs typeface="Arial" pitchFamily="34" charset="178"/>
               </a:rPr>
               <a:t>منتقد</a:t>
             </a:r>
@@ -9666,9 +9543,8 @@
                 <a:solidFill>
                   <a:schemeClr val="accent5"/>
                 </a:solidFill>
-                <a:latin typeface="Vazirmatn" pitchFamily="34" charset="0"/>
-                <a:ea typeface="Vazirmatn" pitchFamily="34" charset="-122"/>
-                <a:cs typeface="Vazirmatn" pitchFamily="34" charset="-120"/>
+                <a:latin typeface="Arial" pitchFamily="34" charset="0"/>
+                <a:cs typeface="Arial" pitchFamily="34" charset="178"/>
               </a:rPr>
               <a:t>دقیقاً چه گفت؟</a:t>
             </a:r>
@@ -9732,9 +9608,8 @@
                 <a:solidFill>
                   <a:schemeClr val="accent1"/>
                 </a:solidFill>
-                <a:latin typeface="Vazirmatn" pitchFamily="34" charset="0"/>
-                <a:ea typeface="Vazirmatn" pitchFamily="34" charset="-122"/>
-                <a:cs typeface="Vazirmatn" pitchFamily="34" charset="-120"/>
+                <a:latin typeface="Arial" pitchFamily="34" charset="0"/>
+                <a:cs typeface="Arial" pitchFamily="34" charset="178"/>
               </a:rPr>
               <a:t>نیاز</a:t>
             </a:r>
@@ -9774,9 +9649,8 @@
                 <a:solidFill>
                   <a:schemeClr val="accent5"/>
                 </a:solidFill>
-                <a:latin typeface="Vazirmatn" pitchFamily="34" charset="0"/>
-                <a:ea typeface="Vazirmatn" pitchFamily="34" charset="-122"/>
-                <a:cs typeface="Vazirmatn" pitchFamily="34" charset="-120"/>
+                <a:latin typeface="Arial" pitchFamily="34" charset="0"/>
+                <a:cs typeface="Arial" pitchFamily="34" charset="178"/>
               </a:rPr>
               <a:t>چه چیزی برایم مهم بود؟</a:t>
             </a:r>
@@ -9840,9 +9714,8 @@
                 <a:solidFill>
                   <a:schemeClr val="accent1"/>
                 </a:solidFill>
-                <a:latin typeface="Vazirmatn" pitchFamily="34" charset="0"/>
-                <a:ea typeface="Vazirmatn" pitchFamily="34" charset="-122"/>
-                <a:cs typeface="Vazirmatn" pitchFamily="34" charset="-120"/>
+                <a:latin typeface="Arial" pitchFamily="34" charset="0"/>
+                <a:cs typeface="Arial" pitchFamily="34" charset="178"/>
               </a:rPr>
               <a:t>محافظت</a:t>
             </a:r>
@@ -9882,9 +9755,8 @@
                 <a:solidFill>
                   <a:schemeClr val="accent5"/>
                 </a:solidFill>
-                <a:latin typeface="Vazirmatn" pitchFamily="34" charset="0"/>
-                <a:ea typeface="Vazirmatn" pitchFamily="34" charset="-122"/>
-                <a:cs typeface="Vazirmatn" pitchFamily="34" charset="-120"/>
+                <a:latin typeface="Arial" pitchFamily="34" charset="0"/>
+                <a:cs typeface="Arial" pitchFamily="34" charset="178"/>
               </a:rPr>
               <a:t>چطور بدون حمله به خودم از خودم حمایت کنم؟</a:t>
             </a:r>
@@ -9948,9 +9820,8 @@
                 <a:solidFill>
                   <a:schemeClr val="accent1"/>
                 </a:solidFill>
-                <a:latin typeface="Vazirmatn" pitchFamily="34" charset="0"/>
-                <a:ea typeface="Vazirmatn" pitchFamily="34" charset="-122"/>
-                <a:cs typeface="Vazirmatn" pitchFamily="34" charset="-120"/>
+                <a:latin typeface="Arial" pitchFamily="34" charset="0"/>
+                <a:cs typeface="Arial" pitchFamily="34" charset="178"/>
               </a:rPr>
               <a:t>اقدام</a:t>
             </a:r>
@@ -9990,9 +9861,8 @@
                 <a:solidFill>
                   <a:schemeClr val="accent5"/>
                 </a:solidFill>
-                <a:latin typeface="Vazirmatn" pitchFamily="34" charset="0"/>
-                <a:ea typeface="Vazirmatn" pitchFamily="34" charset="-122"/>
-                <a:cs typeface="Vazirmatn" pitchFamily="34" charset="-120"/>
+                <a:latin typeface="Arial" pitchFamily="34" charset="0"/>
+                <a:cs typeface="Arial" pitchFamily="34" charset="178"/>
               </a:rPr>
               <a:t>قدم بعدی من چیست؟</a:t>
             </a:r>
@@ -10032,9 +9902,8 @@
                 <a:solidFill>
                   <a:schemeClr val="accent5"/>
                 </a:solidFill>
-                <a:latin typeface="Vazirmatn"/>
-                <a:ea typeface="Vazirmatn"/>
-                <a:cs typeface="Vazirmatn"/>
+                <a:latin typeface="Arial"/>
+                <a:cs typeface="Arial"/>
               </a:defRPr>
             </a:lvl1pPr>
           </a:lstStyle>
@@ -10104,9 +9973,8 @@
                 <a:solidFill>
                   <a:schemeClr val="tx2"/>
                 </a:solidFill>
-                <a:latin typeface="Vazirmatn" pitchFamily="34" charset="0"/>
-                <a:ea typeface="Vazirmatn" pitchFamily="34" charset="-122"/>
-                <a:cs typeface="Vazirmatn" pitchFamily="34" charset="-120"/>
+                <a:latin typeface="Arial" pitchFamily="34" charset="0"/>
+                <a:cs typeface="Arial" pitchFamily="34" charset="178"/>
               </a:rPr>
               <a:t>کجا در این چرخه گیر کرده‌اید؟</a:t>
             </a:r>
@@ -10170,9 +10038,8 @@
                 <a:solidFill>
                   <a:schemeClr val="accent1"/>
                 </a:solidFill>
-                <a:latin typeface="Vazirmatn" pitchFamily="34" charset="0"/>
-                <a:ea typeface="Vazirmatn" pitchFamily="34" charset="-122"/>
-                <a:cs typeface="Vazirmatn" pitchFamily="34" charset="-120"/>
+                <a:latin typeface="Arial" pitchFamily="34" charset="0"/>
+                <a:cs typeface="Arial" pitchFamily="34" charset="178"/>
               </a:rPr>
               <a:t>۱</a:t>
             </a:r>
@@ -10188,8 +10055,8 @@
         </p:nvSpPr>
         <p:spPr>
           <a:xfrm>
-            <a:off x="9649663" y="2971800"/>
-            <a:ext cx="1517904" cy="731520"/>
+            <a:off x="9585655" y="2971800"/>
+            <a:ext cx="1645920" cy="731520"/>
           </a:xfrm>
           <a:prstGeom prst="rect">
             <a:avLst/>
@@ -10208,17 +10075,16 @@
               <a:buNone/>
             </a:pPr>
             <a:r>
-              <a:rPr lang="fa-IR" altLang="en-US" sz="2000" b="1" dirty="0">
+              <a:rPr lang="fa-IR" altLang="en-US" sz="1800" b="1" dirty="0">
                 <a:solidFill>
                   <a:schemeClr val="tx1"/>
                 </a:solidFill>
-                <a:latin typeface="Vazirmatn" pitchFamily="34" charset="0"/>
-                <a:ea typeface="Vazirmatn" pitchFamily="34" charset="-122"/>
-                <a:cs typeface="Vazirmatn" pitchFamily="34" charset="-120"/>
+                <a:latin typeface="Arial" pitchFamily="34" charset="0"/>
+                <a:cs typeface="Arial" pitchFamily="34" charset="178"/>
               </a:rPr>
               <a:t>احساس</a:t>
             </a:r>
-            <a:endParaRPr lang="fa-IR" sz="2000" dirty="0"/>
+            <a:endParaRPr lang="fa-IR" sz="1800" dirty="0"/>
           </a:p>
         </p:txBody>
       </p:sp>
@@ -10230,8 +10096,8 @@
         </p:nvSpPr>
         <p:spPr>
           <a:xfrm>
-            <a:off x="9649663" y="3657600"/>
-            <a:ext cx="1517904" cy="1600200"/>
+            <a:off x="9585655" y="3657600"/>
+            <a:ext cx="1645920" cy="1600200"/>
           </a:xfrm>
           <a:prstGeom prst="rect">
             <a:avLst/>
@@ -10254,9 +10120,8 @@
                 <a:solidFill>
                   <a:schemeClr val="accent3"/>
                 </a:solidFill>
-                <a:latin typeface="Vazirmatn" pitchFamily="34" charset="0"/>
-                <a:ea typeface="Vazirmatn" pitchFamily="34" charset="-122"/>
-                <a:cs typeface="Vazirmatn" pitchFamily="34" charset="-120"/>
+                <a:latin typeface="Arial" pitchFamily="34" charset="0"/>
+                <a:cs typeface="Arial" pitchFamily="34" charset="178"/>
               </a:rPr>
               <a:t>نمی‌فهمم واقعاً چه احساسی دارم.</a:t>
             </a:r>
@@ -10320,9 +10185,8 @@
                 <a:solidFill>
                   <a:schemeClr val="accent1"/>
                 </a:solidFill>
-                <a:latin typeface="Vazirmatn" pitchFamily="34" charset="0"/>
-                <a:ea typeface="Vazirmatn" pitchFamily="34" charset="-122"/>
-                <a:cs typeface="Vazirmatn" pitchFamily="34" charset="-120"/>
+                <a:latin typeface="Arial" pitchFamily="34" charset="0"/>
+                <a:cs typeface="Arial" pitchFamily="34" charset="178"/>
               </a:rPr>
               <a:t>۲</a:t>
             </a:r>
@@ -10338,8 +10202,8 @@
         </p:nvSpPr>
         <p:spPr>
           <a:xfrm>
-            <a:off x="7493279" y="2971800"/>
-            <a:ext cx="1517904" cy="731520"/>
+            <a:off x="7429271" y="2971800"/>
+            <a:ext cx="1645920" cy="731520"/>
           </a:xfrm>
           <a:prstGeom prst="rect">
             <a:avLst/>
@@ -10358,17 +10222,16 @@
               <a:buNone/>
             </a:pPr>
             <a:r>
-              <a:rPr lang="fa-IR" altLang="en-US" sz="2000" b="1" dirty="0">
+              <a:rPr lang="fa-IR" altLang="en-US" sz="1800" b="1" dirty="0">
                 <a:solidFill>
                   <a:schemeClr val="tx1"/>
                 </a:solidFill>
-                <a:latin typeface="Vazirmatn" pitchFamily="34" charset="0"/>
-                <a:ea typeface="Vazirmatn" pitchFamily="34" charset="-122"/>
-                <a:cs typeface="Vazirmatn" pitchFamily="34" charset="-120"/>
+                <a:latin typeface="Arial" pitchFamily="34" charset="0"/>
+                <a:cs typeface="Arial" pitchFamily="34" charset="178"/>
               </a:rPr>
               <a:t>خودسرزنشی</a:t>
             </a:r>
-            <a:endParaRPr lang="fa-IR" sz="2000" dirty="0"/>
+            <a:endParaRPr lang="fa-IR" sz="1800" dirty="0"/>
           </a:p>
         </p:txBody>
       </p:sp>
@@ -10380,8 +10243,8 @@
         </p:nvSpPr>
         <p:spPr>
           <a:xfrm>
-            <a:off x="7493279" y="3657600"/>
-            <a:ext cx="1517904" cy="1600200"/>
+            <a:off x="7429271" y="3657600"/>
+            <a:ext cx="1645920" cy="1600200"/>
           </a:xfrm>
           <a:prstGeom prst="rect">
             <a:avLst/>
@@ -10404,9 +10267,8 @@
                 <a:solidFill>
                   <a:schemeClr val="accent3"/>
                 </a:solidFill>
-                <a:latin typeface="Vazirmatn" pitchFamily="34" charset="0"/>
-                <a:ea typeface="Vazirmatn" pitchFamily="34" charset="-122"/>
-                <a:cs typeface="Vazirmatn" pitchFamily="34" charset="-120"/>
+                <a:latin typeface="Arial" pitchFamily="34" charset="0"/>
+                <a:cs typeface="Arial" pitchFamily="34" charset="178"/>
               </a:rPr>
               <a:t>احساس را می‌فهمم، اما خودم را مقصر می‌کنم.</a:t>
             </a:r>
@@ -10470,9 +10332,8 @@
                 <a:solidFill>
                   <a:schemeClr val="accent1"/>
                 </a:solidFill>
-                <a:latin typeface="Vazirmatn" pitchFamily="34" charset="0"/>
-                <a:ea typeface="Vazirmatn" pitchFamily="34" charset="-122"/>
-                <a:cs typeface="Vazirmatn" pitchFamily="34" charset="-120"/>
+                <a:latin typeface="Arial" pitchFamily="34" charset="0"/>
+                <a:cs typeface="Arial" pitchFamily="34" charset="178"/>
               </a:rPr>
               <a:t>۳</a:t>
             </a:r>
@@ -10488,8 +10349,8 @@
         </p:nvSpPr>
         <p:spPr>
           <a:xfrm>
-            <a:off x="5336896" y="2971800"/>
-            <a:ext cx="1517904" cy="731520"/>
+            <a:off x="5272888" y="2971800"/>
+            <a:ext cx="1645920" cy="731520"/>
           </a:xfrm>
           <a:prstGeom prst="rect">
             <a:avLst/>
@@ -10508,17 +10369,16 @@
               <a:buNone/>
             </a:pPr>
             <a:r>
-              <a:rPr lang="fa-IR" altLang="en-US" sz="2000" b="1" dirty="0">
+              <a:rPr lang="fa-IR" altLang="en-US" sz="1800" b="1" dirty="0">
                 <a:solidFill>
                   <a:schemeClr val="tx1"/>
                 </a:solidFill>
-                <a:latin typeface="Vazirmatn" pitchFamily="34" charset="0"/>
-                <a:ea typeface="Vazirmatn" pitchFamily="34" charset="-122"/>
-                <a:cs typeface="Vazirmatn" pitchFamily="34" charset="-120"/>
+                <a:latin typeface="Arial" pitchFamily="34" charset="0"/>
+                <a:cs typeface="Arial" pitchFamily="34" charset="178"/>
               </a:rPr>
               <a:t>نشخوار</a:t>
             </a:r>
-            <a:endParaRPr lang="fa-IR" sz="2000" dirty="0"/>
+            <a:endParaRPr lang="fa-IR" sz="1800" dirty="0"/>
           </a:p>
         </p:txBody>
       </p:sp>
@@ -10530,8 +10390,8 @@
         </p:nvSpPr>
         <p:spPr>
           <a:xfrm>
-            <a:off x="5336896" y="3657600"/>
-            <a:ext cx="1517904" cy="1600200"/>
+            <a:off x="5272888" y="3657600"/>
+            <a:ext cx="1645920" cy="1600200"/>
           </a:xfrm>
           <a:prstGeom prst="rect">
             <a:avLst/>
@@ -10554,9 +10414,8 @@
                 <a:solidFill>
                   <a:schemeClr val="accent3"/>
                 </a:solidFill>
-                <a:latin typeface="Vazirmatn" pitchFamily="34" charset="0"/>
-                <a:ea typeface="Vazirmatn" pitchFamily="34" charset="-122"/>
-                <a:cs typeface="Vazirmatn" pitchFamily="34" charset="-120"/>
+                <a:latin typeface="Arial" pitchFamily="34" charset="0"/>
+                <a:cs typeface="Arial" pitchFamily="34" charset="178"/>
               </a:rPr>
               <a:t>می‌فهمم ناراحتم، اما نمی‌توانم از فکر کردن بیرون بیایم.</a:t>
             </a:r>
@@ -10620,9 +10479,8 @@
                 <a:solidFill>
                   <a:schemeClr val="accent1"/>
                 </a:solidFill>
-                <a:latin typeface="Vazirmatn" pitchFamily="34" charset="0"/>
-                <a:ea typeface="Vazirmatn" pitchFamily="34" charset="-122"/>
-                <a:cs typeface="Vazirmatn" pitchFamily="34" charset="-120"/>
+                <a:latin typeface="Arial" pitchFamily="34" charset="0"/>
+                <a:cs typeface="Arial" pitchFamily="34" charset="178"/>
               </a:rPr>
               <a:t>۴</a:t>
             </a:r>
@@ -10638,8 +10496,8 @@
         </p:nvSpPr>
         <p:spPr>
           <a:xfrm>
-            <a:off x="3180512" y="2971800"/>
-            <a:ext cx="1517904" cy="731520"/>
+            <a:off x="3116504" y="2971800"/>
+            <a:ext cx="1645920" cy="731520"/>
           </a:xfrm>
           <a:prstGeom prst="rect">
             <a:avLst/>
@@ -10658,17 +10516,16 @@
               <a:buNone/>
             </a:pPr>
             <a:r>
-              <a:rPr lang="fa-IR" altLang="en-US" sz="2000" b="1" dirty="0">
+              <a:rPr lang="fa-IR" altLang="en-US" sz="1800" b="1" dirty="0">
                 <a:solidFill>
                   <a:schemeClr val="tx1"/>
                 </a:solidFill>
-                <a:latin typeface="Vazirmatn" pitchFamily="34" charset="0"/>
-                <a:ea typeface="Vazirmatn" pitchFamily="34" charset="-122"/>
-                <a:cs typeface="Vazirmatn" pitchFamily="34" charset="-120"/>
+                <a:latin typeface="Arial" pitchFamily="34" charset="0"/>
+                <a:cs typeface="Arial" pitchFamily="34" charset="178"/>
               </a:rPr>
               <a:t>اقدام</a:t>
             </a:r>
-            <a:endParaRPr lang="fa-IR" sz="2000" dirty="0"/>
+            <a:endParaRPr lang="fa-IR" sz="1800" dirty="0"/>
           </a:p>
         </p:txBody>
       </p:sp>
@@ -10680,8 +10537,8 @@
         </p:nvSpPr>
         <p:spPr>
           <a:xfrm>
-            <a:off x="3180512" y="3657600"/>
-            <a:ext cx="1517904" cy="1600200"/>
+            <a:off x="3116504" y="3657600"/>
+            <a:ext cx="1645920" cy="1600200"/>
           </a:xfrm>
           <a:prstGeom prst="rect">
             <a:avLst/>
@@ -10704,9 +10561,8 @@
                 <a:solidFill>
                   <a:schemeClr val="accent3"/>
                 </a:solidFill>
-                <a:latin typeface="Vazirmatn" pitchFamily="34" charset="0"/>
-                <a:ea typeface="Vazirmatn" pitchFamily="34" charset="-122"/>
-                <a:cs typeface="Vazirmatn" pitchFamily="34" charset="-120"/>
+                <a:latin typeface="Arial" pitchFamily="34" charset="0"/>
+                <a:cs typeface="Arial" pitchFamily="34" charset="178"/>
               </a:rPr>
               <a:t>می‌دانم چه می‌خواهم، اما نمی‌توانم از خودم دفاع کنم.</a:t>
             </a:r>
@@ -10770,9 +10626,8 @@
                 <a:solidFill>
                   <a:schemeClr val="accent2"/>
                 </a:solidFill>
-                <a:latin typeface="Vazirmatn" pitchFamily="34" charset="0"/>
-                <a:ea typeface="Vazirmatn" pitchFamily="34" charset="-122"/>
-                <a:cs typeface="Vazirmatn" pitchFamily="34" charset="-120"/>
+                <a:latin typeface="Arial" pitchFamily="34" charset="0"/>
+                <a:cs typeface="Arial" pitchFamily="34" charset="178"/>
               </a:rPr>
               <a:t>۵</a:t>
             </a:r>
@@ -10788,8 +10643,8 @@
         </p:nvSpPr>
         <p:spPr>
           <a:xfrm>
-            <a:off x="1024128" y="2971800"/>
-            <a:ext cx="1517904" cy="731520"/>
+            <a:off x="960120" y="2971800"/>
+            <a:ext cx="1645920" cy="731520"/>
           </a:xfrm>
           <a:prstGeom prst="rect">
             <a:avLst/>
@@ -10808,17 +10663,16 @@
               <a:buNone/>
             </a:pPr>
             <a:r>
-              <a:rPr lang="fa-IR" altLang="en-US" sz="2000" b="1" dirty="0">
+              <a:rPr lang="fa-IR" altLang="en-US" sz="1800" b="1" dirty="0">
                 <a:solidFill>
                   <a:schemeClr val="tx1"/>
                 </a:solidFill>
-                <a:latin typeface="Vazirmatn" pitchFamily="34" charset="0"/>
-                <a:ea typeface="Vazirmatn" pitchFamily="34" charset="-122"/>
-                <a:cs typeface="Vazirmatn" pitchFamily="34" charset="-120"/>
+                <a:latin typeface="Arial" pitchFamily="34" charset="0"/>
+                <a:cs typeface="Arial" pitchFamily="34" charset="178"/>
               </a:rPr>
               <a:t>الگوی تکرارشونده</a:t>
             </a:r>
-            <a:endParaRPr lang="fa-IR" sz="2000" dirty="0"/>
+            <a:endParaRPr lang="fa-IR" sz="1800" dirty="0"/>
           </a:p>
         </p:txBody>
       </p:sp>
@@ -10830,8 +10684,8 @@
         </p:nvSpPr>
         <p:spPr>
           <a:xfrm>
-            <a:off x="1024128" y="3657600"/>
-            <a:ext cx="1517904" cy="1600200"/>
+            <a:off x="960120" y="3657600"/>
+            <a:ext cx="1645920" cy="1600200"/>
           </a:xfrm>
           <a:prstGeom prst="rect">
             <a:avLst/>
@@ -10854,9 +10708,8 @@
                 <a:solidFill>
                   <a:schemeClr val="accent3"/>
                 </a:solidFill>
-                <a:latin typeface="Vazirmatn" pitchFamily="34" charset="0"/>
-                <a:ea typeface="Vazirmatn" pitchFamily="34" charset="-122"/>
-                <a:cs typeface="Vazirmatn" pitchFamily="34" charset="-120"/>
+                <a:latin typeface="Arial" pitchFamily="34" charset="0"/>
+                <a:cs typeface="Arial" pitchFamily="34" charset="178"/>
               </a:rPr>
               <a:t>این چرخه بارها در روابط، کار یا تصمیم‌ها تکرار می‌شود.</a:t>
             </a:r>
@@ -10893,9 +10746,8 @@
                 <a:solidFill>
                   <a:schemeClr val="accent5"/>
                 </a:solidFill>
-                <a:latin typeface="Vazirmatn" pitchFamily="34" charset="0"/>
-                <a:ea typeface="Vazirmatn" pitchFamily="34" charset="-122"/>
-                <a:cs typeface="Vazirmatn" pitchFamily="34" charset="-120"/>
+                <a:latin typeface="Arial" pitchFamily="34" charset="0"/>
+                <a:cs typeface="Arial" pitchFamily="34" charset="178"/>
               </a:rPr>
               <a:t>این یک نقشه خودمشاهده‌گری است، نه خودتشخیصی.</a:t>
             </a:r>
@@ -10935,9 +10787,8 @@
                 <a:solidFill>
                   <a:schemeClr val="accent5"/>
                 </a:solidFill>
-                <a:latin typeface="Vazirmatn"/>
-                <a:ea typeface="Vazirmatn"/>
-                <a:cs typeface="Vazirmatn"/>
+                <a:latin typeface="Arial"/>
+                <a:cs typeface="Arial"/>
               </a:defRPr>
             </a:lvl1pPr>
           </a:lstStyle>
@@ -11005,9 +10856,8 @@
                 <a:solidFill>
                   <a:schemeClr val="accent5"/>
                 </a:solidFill>
-                <a:latin typeface="Vazirmatn" pitchFamily="34" charset="0"/>
-                <a:ea typeface="Vazirmatn" pitchFamily="34" charset="-122"/>
-                <a:cs typeface="Vazirmatn" pitchFamily="34" charset="-120"/>
+                <a:latin typeface="Arial" pitchFamily="34" charset="0"/>
+                <a:cs typeface="Arial" pitchFamily="34" charset="178"/>
               </a:rPr>
               <a:t>آخرین بار که کسی ناراحتتان کرد...</a:t>
             </a:r>
@@ -11044,9 +10894,8 @@
                 <a:solidFill>
                   <a:schemeClr val="tx1"/>
                 </a:solidFill>
-                <a:latin typeface="Vazirmatn" pitchFamily="34" charset="0"/>
-                <a:ea typeface="Vazirmatn" pitchFamily="34" charset="-122"/>
-                <a:cs typeface="Vazirmatn" pitchFamily="34" charset="-120"/>
+                <a:latin typeface="Arial" pitchFamily="34" charset="0"/>
+                <a:cs typeface="Arial" pitchFamily="34" charset="178"/>
               </a:rPr>
               <a:t>با او چه کردید؟</a:t>
             </a:r>
@@ -11083,9 +10932,8 @@
                 <a:solidFill>
                   <a:schemeClr val="tx1"/>
                 </a:solidFill>
-                <a:latin typeface="Vazirmatn" pitchFamily="34" charset="0"/>
-                <a:ea typeface="Vazirmatn" pitchFamily="34" charset="-122"/>
-                <a:cs typeface="Vazirmatn" pitchFamily="34" charset="-120"/>
+                <a:latin typeface="Arial" pitchFamily="34" charset="0"/>
+                <a:cs typeface="Arial" pitchFamily="34" charset="178"/>
               </a:rPr>
               <a:t>و با </a:t>
             </a:r>
@@ -11097,9 +10945,8 @@
                 <a:solidFill>
                   <a:schemeClr val="accent1"/>
                 </a:solidFill>
-                <a:latin typeface="Vazirmatn" pitchFamily="34" charset="0"/>
-                <a:ea typeface="Vazirmatn" pitchFamily="34" charset="-122"/>
-                <a:cs typeface="Vazirmatn" pitchFamily="34" charset="-120"/>
+                <a:latin typeface="Arial" pitchFamily="34" charset="0"/>
+                <a:cs typeface="Arial" pitchFamily="34" charset="178"/>
               </a:rPr>
               <a:t>خودتان</a:t>
             </a:r>
@@ -11111,9 +10958,8 @@
                 <a:solidFill>
                   <a:schemeClr val="tx1"/>
                 </a:solidFill>
-                <a:latin typeface="Vazirmatn" pitchFamily="34" charset="0"/>
-                <a:ea typeface="Vazirmatn" pitchFamily="34" charset="-122"/>
-                <a:cs typeface="Vazirmatn" pitchFamily="34" charset="-120"/>
+                <a:latin typeface="Arial" pitchFamily="34" charset="0"/>
+                <a:cs typeface="Arial" pitchFamily="34" charset="178"/>
               </a:rPr>
               <a:t> چه کردید؟</a:t>
             </a:r>
@@ -11153,9 +10999,8 @@
                 <a:solidFill>
                   <a:schemeClr val="accent5"/>
                 </a:solidFill>
-                <a:latin typeface="Vazirmatn"/>
-                <a:ea typeface="Vazirmatn"/>
-                <a:cs typeface="Vazirmatn"/>
+                <a:latin typeface="Arial"/>
+                <a:cs typeface="Arial"/>
               </a:defRPr>
             </a:lvl1pPr>
           </a:lstStyle>
@@ -11225,9 +11070,8 @@
                 <a:solidFill>
                   <a:schemeClr val="bg1"/>
                 </a:solidFill>
-                <a:latin typeface="Vazirmatn" pitchFamily="34" charset="0"/>
-                <a:ea typeface="Vazirmatn" pitchFamily="34" charset="-122"/>
-                <a:cs typeface="Vazirmatn" pitchFamily="34" charset="-120"/>
+                <a:latin typeface="Arial" pitchFamily="34" charset="0"/>
+                <a:cs typeface="Arial" pitchFamily="34" charset="178"/>
               </a:rPr>
               <a:t>شناختن چرخه با تغییر دادن آن فرق دارد.</a:t>
             </a:r>
@@ -11267,9 +11111,8 @@
                 <a:solidFill>
                   <a:schemeClr val="bg1"/>
                 </a:solidFill>
-                <a:latin typeface="Vazirmatn" pitchFamily="34" charset="0"/>
-                <a:ea typeface="Vazirmatn" pitchFamily="34" charset="-122"/>
-                <a:cs typeface="Vazirmatn" pitchFamily="34" charset="-120"/>
+                <a:latin typeface="Arial" pitchFamily="34" charset="0"/>
+                <a:cs typeface="Arial" pitchFamily="34" charset="178"/>
               </a:rPr>
               <a:t>اگر این الگو برای شما تکرارشونده است،</a:t>
             </a:r>
@@ -11287,9 +11130,8 @@
                 <a:solidFill>
                   <a:schemeClr val="bg1"/>
                 </a:solidFill>
-                <a:latin typeface="Vazirmatn" pitchFamily="34" charset="0"/>
-                <a:ea typeface="Vazirmatn" pitchFamily="34" charset="-122"/>
-                <a:cs typeface="Vazirmatn" pitchFamily="34" charset="-120"/>
+                <a:latin typeface="Arial" pitchFamily="34" charset="0"/>
+                <a:cs typeface="Arial" pitchFamily="34" charset="178"/>
               </a:rPr>
               <a:t>موضوع فقط «فهمیدن» نیست.</a:t>
             </a:r>
@@ -11326,9 +11168,8 @@
                 <a:solidFill>
                   <a:srgbClr val="DCE4DF"/>
                 </a:solidFill>
-                <a:latin typeface="Vazirmatn" pitchFamily="34" charset="0"/>
-                <a:ea typeface="Vazirmatn" pitchFamily="34" charset="-122"/>
-                <a:cs typeface="Vazirmatn" pitchFamily="34" charset="-120"/>
+                <a:latin typeface="Arial" pitchFamily="34" charset="0"/>
+                <a:cs typeface="Arial" pitchFamily="34" charset="178"/>
               </a:rPr>
               <a:t>لازم است ببینیم چرخه در زندگی واقعی شما:</a:t>
             </a:r>
@@ -11365,9 +11206,8 @@
                 <a:solidFill>
                   <a:schemeClr val="bg1"/>
                 </a:solidFill>
-                <a:latin typeface="Vazirmatn" pitchFamily="34" charset="0"/>
-                <a:ea typeface="Vazirmatn" pitchFamily="34" charset="-122"/>
-                <a:cs typeface="Vazirmatn" pitchFamily="34" charset="-120"/>
+                <a:latin typeface="Arial" pitchFamily="34" charset="0"/>
+                <a:cs typeface="Arial" pitchFamily="34" charset="178"/>
               </a:rPr>
               <a:t>کجا شروع می‌شود؟</a:t>
             </a:r>
@@ -11404,9 +11244,8 @@
                 <a:solidFill>
                   <a:schemeClr val="bg1"/>
                 </a:solidFill>
-                <a:latin typeface="Vazirmatn" pitchFamily="34" charset="0"/>
-                <a:ea typeface="Vazirmatn" pitchFamily="34" charset="-122"/>
-                <a:cs typeface="Vazirmatn" pitchFamily="34" charset="-120"/>
+                <a:latin typeface="Arial" pitchFamily="34" charset="0"/>
+                <a:cs typeface="Arial" pitchFamily="34" charset="178"/>
               </a:rPr>
               <a:t>چطور حفظ می‌شود؟</a:t>
             </a:r>
@@ -11443,9 +11282,8 @@
                 <a:solidFill>
                   <a:schemeClr val="bg1"/>
                 </a:solidFill>
-                <a:latin typeface="Vazirmatn" pitchFamily="34" charset="0"/>
-                <a:ea typeface="Vazirmatn" pitchFamily="34" charset="-122"/>
-                <a:cs typeface="Vazirmatn" pitchFamily="34" charset="-120"/>
+                <a:latin typeface="Arial" pitchFamily="34" charset="0"/>
+                <a:cs typeface="Arial" pitchFamily="34" charset="178"/>
               </a:rPr>
               <a:t>و چرا دوباره تکرار می‌شود؟</a:t>
             </a:r>
@@ -11482,9 +11320,8 @@
                 <a:solidFill>
                   <a:srgbClr val="DCE4DF"/>
                 </a:solidFill>
-                <a:latin typeface="Vazirmatn" pitchFamily="34" charset="0"/>
-                <a:ea typeface="Vazirmatn" pitchFamily="34" charset="-122"/>
-                <a:cs typeface="Vazirmatn" pitchFamily="34" charset="-120"/>
+                <a:latin typeface="Arial" pitchFamily="34" charset="0"/>
+                <a:cs typeface="Arial" pitchFamily="34" charset="178"/>
               </a:rPr>
               <a:t>محرک ← احساس ← منتقد ← نیاز ← پاسخ ← اقدام</a:t>
             </a:r>
@@ -11524,9 +11361,8 @@
                 <a:solidFill>
                   <a:schemeClr val="bg1"/>
                 </a:solidFill>
-                <a:latin typeface="Vazirmatn"/>
-                <a:ea typeface="Vazirmatn"/>
-                <a:cs typeface="Vazirmatn"/>
+                <a:latin typeface="Arial"/>
+                <a:cs typeface="Arial"/>
               </a:defRPr>
             </a:lvl1pPr>
           </a:lstStyle>
@@ -11596,9 +11432,8 @@
                 <a:solidFill>
                   <a:schemeClr val="tx2"/>
                 </a:solidFill>
-                <a:latin typeface="Vazirmatn" pitchFamily="34" charset="0"/>
-                <a:ea typeface="Vazirmatn" pitchFamily="34" charset="-122"/>
-                <a:cs typeface="Vazirmatn" pitchFamily="34" charset="-120"/>
+                <a:latin typeface="Arial" pitchFamily="34" charset="0"/>
+                <a:cs typeface="Arial" pitchFamily="34" charset="178"/>
               </a:rPr>
               <a:t>منابع اصلی</a:t>
             </a:r>
@@ -11635,9 +11470,8 @@
                 <a:solidFill>
                   <a:schemeClr val="tx1"/>
                 </a:solidFill>
-                <a:latin typeface="Vazirmatn" pitchFamily="34" charset="0"/>
-                <a:ea typeface="Vazirmatn" pitchFamily="34" charset="-122"/>
-                <a:cs typeface="Vazirmatn" pitchFamily="34" charset="-120"/>
+                <a:latin typeface="Arial" pitchFamily="34" charset="0"/>
+                <a:cs typeface="Arial" pitchFamily="34" charset="178"/>
               </a:rPr>
               <a:t>Šoková, B., Greškovičová, K., Halamová, J., et al. (2025).</a:t>
             </a:r>
@@ -11652,9 +11486,8 @@
                 <a:solidFill>
                   <a:schemeClr val="tx1"/>
                 </a:solidFill>
-                <a:latin typeface="Vazirmatn" pitchFamily="34" charset="0"/>
-                <a:ea typeface="Vazirmatn" pitchFamily="34" charset="-122"/>
-                <a:cs typeface="Vazirmatn" pitchFamily="34" charset="-120"/>
+                <a:latin typeface="Arial" pitchFamily="34" charset="0"/>
+                <a:cs typeface="Arial" pitchFamily="34" charset="178"/>
               </a:rPr>
               <a:t>Breaking the vicious cycles of self-criticism: a qualitative study on the best practices of overcoming one's inner critic.</a:t>
             </a:r>
@@ -11669,9 +11502,8 @@
                 <a:solidFill>
                   <a:schemeClr val="accent5"/>
                 </a:solidFill>
-                <a:latin typeface="Vazirmatn" pitchFamily="34" charset="0"/>
-                <a:ea typeface="Vazirmatn" pitchFamily="34" charset="-122"/>
-                <a:cs typeface="Vazirmatn" pitchFamily="34" charset="-120"/>
+                <a:latin typeface="Arial" pitchFamily="34" charset="0"/>
+                <a:cs typeface="Arial" pitchFamily="34" charset="178"/>
               </a:rPr>
               <a:t>BMC Psychology, 13, 266.</a:t>
             </a:r>
@@ -11686,9 +11518,8 @@
                 <a:solidFill>
                   <a:schemeClr val="accent2"/>
                 </a:solidFill>
-                <a:latin typeface="Vazirmatn" pitchFamily="34" charset="0"/>
-                <a:ea typeface="Vazirmatn" pitchFamily="34" charset="-122"/>
-                <a:cs typeface="Vazirmatn" pitchFamily="34" charset="-120"/>
+                <a:latin typeface="Arial" pitchFamily="34" charset="0"/>
+                <a:cs typeface="Arial" pitchFamily="34" charset="178"/>
               </a:rPr>
               <a:t>DOI: 10.1186/s40359-024-02250-2</a:t>
             </a:r>
@@ -11725,9 +11556,8 @@
                 <a:solidFill>
                   <a:schemeClr val="tx1"/>
                 </a:solidFill>
-                <a:latin typeface="Vazirmatn" pitchFamily="34" charset="0"/>
-                <a:ea typeface="Vazirmatn" pitchFamily="34" charset="-122"/>
-                <a:cs typeface="Vazirmatn" pitchFamily="34" charset="-120"/>
+                <a:latin typeface="Arial" pitchFamily="34" charset="0"/>
+                <a:cs typeface="Arial" pitchFamily="34" charset="178"/>
               </a:rPr>
               <a:t>Oblak, A., Rigler, S., Kovačič, N., et al. (2026).</a:t>
             </a:r>
@@ -11742,9 +11572,8 @@
                 <a:solidFill>
                   <a:schemeClr val="tx1"/>
                 </a:solidFill>
-                <a:latin typeface="Vazirmatn" pitchFamily="34" charset="0"/>
-                <a:ea typeface="Vazirmatn" pitchFamily="34" charset="-122"/>
-                <a:cs typeface="Vazirmatn" pitchFamily="34" charset="-120"/>
+                <a:latin typeface="Arial" pitchFamily="34" charset="0"/>
+                <a:cs typeface="Arial" pitchFamily="34" charset="178"/>
               </a:rPr>
               <a:t>The lifeworld of people who ruminate: a qualitative phenomenological study.</a:t>
             </a:r>
@@ -11759,9 +11588,8 @@
                 <a:solidFill>
                   <a:schemeClr val="accent5"/>
                 </a:solidFill>
-                <a:latin typeface="Vazirmatn" pitchFamily="34" charset="0"/>
-                <a:ea typeface="Vazirmatn" pitchFamily="34" charset="-122"/>
-                <a:cs typeface="Vazirmatn" pitchFamily="34" charset="-120"/>
+                <a:latin typeface="Arial" pitchFamily="34" charset="0"/>
+                <a:cs typeface="Arial" pitchFamily="34" charset="178"/>
               </a:rPr>
               <a:t>Frontiers in Psychiatry, 17, 1649971.</a:t>
             </a:r>
@@ -11776,9 +11604,8 @@
                 <a:solidFill>
                   <a:schemeClr val="accent2"/>
                 </a:solidFill>
-                <a:latin typeface="Vazirmatn" pitchFamily="34" charset="0"/>
-                <a:ea typeface="Vazirmatn" pitchFamily="34" charset="-122"/>
-                <a:cs typeface="Vazirmatn" pitchFamily="34" charset="-120"/>
+                <a:latin typeface="Arial" pitchFamily="34" charset="0"/>
+                <a:cs typeface="Arial" pitchFamily="34" charset="178"/>
               </a:rPr>
               <a:t>DOI: 10.3389/fpsyt.2026.1649971</a:t>
             </a:r>
@@ -11815,9 +11642,8 @@
                 <a:solidFill>
                   <a:schemeClr val="tx1"/>
                 </a:solidFill>
-                <a:latin typeface="Vazirmatn" pitchFamily="34" charset="0"/>
-                <a:ea typeface="Vazirmatn" pitchFamily="34" charset="-122"/>
-                <a:cs typeface="Vazirmatn" pitchFamily="34" charset="-120"/>
+                <a:latin typeface="Arial" pitchFamily="34" charset="0"/>
+                <a:cs typeface="Arial" pitchFamily="34" charset="178"/>
               </a:rPr>
               <a:t>Khan, S., Rehna, T., &amp; Butt, T. A. (2024).</a:t>
             </a:r>
@@ -11832,9 +11658,8 @@
                 <a:solidFill>
                   <a:schemeClr val="tx1"/>
                 </a:solidFill>
-                <a:latin typeface="Vazirmatn" pitchFamily="34" charset="0"/>
-                <a:ea typeface="Vazirmatn" pitchFamily="34" charset="-122"/>
-                <a:cs typeface="Vazirmatn" pitchFamily="34" charset="-120"/>
+                <a:latin typeface="Arial" pitchFamily="34" charset="0"/>
+                <a:cs typeface="Arial" pitchFamily="34" charset="178"/>
               </a:rPr>
               <a:t>The emotional surge: in-depth qualitative exploration of rumination and emotional turbulence in non-suicidal self-injurers.</a:t>
             </a:r>
@@ -11849,9 +11674,8 @@
                 <a:solidFill>
                   <a:schemeClr val="accent5"/>
                 </a:solidFill>
-                <a:latin typeface="Vazirmatn" pitchFamily="34" charset="0"/>
-                <a:ea typeface="Vazirmatn" pitchFamily="34" charset="-122"/>
-                <a:cs typeface="Vazirmatn" pitchFamily="34" charset="-120"/>
+                <a:latin typeface="Arial" pitchFamily="34" charset="0"/>
+                <a:cs typeface="Arial" pitchFamily="34" charset="178"/>
               </a:rPr>
               <a:t>Frontiers in Psychology, 15, 1449110.</a:t>
             </a:r>
@@ -11866,9 +11690,8 @@
                 <a:solidFill>
                   <a:schemeClr val="accent2"/>
                 </a:solidFill>
-                <a:latin typeface="Vazirmatn" pitchFamily="34" charset="0"/>
-                <a:ea typeface="Vazirmatn" pitchFamily="34" charset="-122"/>
-                <a:cs typeface="Vazirmatn" pitchFamily="34" charset="-120"/>
+                <a:latin typeface="Arial" pitchFamily="34" charset="0"/>
+                <a:cs typeface="Arial" pitchFamily="34" charset="178"/>
               </a:rPr>
               <a:t>DOI: 10.3389/fpsyg.2024.1449110</a:t>
             </a:r>
@@ -11905,9 +11728,8 @@
                 <a:solidFill>
                   <a:schemeClr val="accent5"/>
                 </a:solidFill>
-                <a:latin typeface="Vazirmatn" pitchFamily="34" charset="0"/>
-                <a:ea typeface="Vazirmatn" pitchFamily="34" charset="-122"/>
-                <a:cs typeface="Vazirmatn" pitchFamily="34" charset="-120"/>
+                <a:latin typeface="Arial" pitchFamily="34" charset="0"/>
+                <a:cs typeface="Arial" pitchFamily="34" charset="178"/>
               </a:rPr>
               <a:t>مقاله سوم روی جمعیت NSSI انجام شده و یافته‌های آن نباید به مخاطب عمومی تعمیم مستقیم داده شوند.</a:t>
             </a:r>
@@ -11947,9 +11769,8 @@
                 <a:solidFill>
                   <a:schemeClr val="accent5"/>
                 </a:solidFill>
-                <a:latin typeface="Vazirmatn"/>
-                <a:ea typeface="Vazirmatn"/>
-                <a:cs typeface="Vazirmatn"/>
+                <a:latin typeface="Arial"/>
+                <a:cs typeface="Arial"/>
               </a:defRPr>
             </a:lvl1pPr>
           </a:lstStyle>
@@ -12019,9 +11840,8 @@
                 <a:solidFill>
                   <a:schemeClr val="tx2"/>
                 </a:solidFill>
-                <a:latin typeface="Vazirmatn" pitchFamily="34" charset="0"/>
-                <a:ea typeface="Vazirmatn" pitchFamily="34" charset="-122"/>
-                <a:cs typeface="Vazirmatn" pitchFamily="34" charset="-120"/>
+                <a:latin typeface="Arial" pitchFamily="34" charset="0"/>
+                <a:cs typeface="Arial" pitchFamily="34" charset="178"/>
               </a:rPr>
               <a:t>مسئله از همین‌جا شروع می‌شود</a:t>
             </a:r>
@@ -12058,9 +11878,8 @@
                 <a:solidFill>
                   <a:schemeClr val="accent2"/>
                 </a:solidFill>
-                <a:latin typeface="Vazirmatn" pitchFamily="34" charset="0"/>
-                <a:ea typeface="Vazirmatn" pitchFamily="34" charset="-122"/>
-                <a:cs typeface="Vazirmatn" pitchFamily="34" charset="-120"/>
+                <a:latin typeface="Arial" pitchFamily="34" charset="0"/>
+                <a:cs typeface="Arial" pitchFamily="34" charset="178"/>
               </a:rPr>
               <a:t>مسیر اول</a:t>
             </a:r>
@@ -12097,9 +11916,8 @@
                 <a:solidFill>
                   <a:schemeClr val="tx1"/>
                 </a:solidFill>
-                <a:latin typeface="Vazirmatn" pitchFamily="34" charset="0"/>
-                <a:ea typeface="Vazirmatn" pitchFamily="34" charset="-122"/>
-                <a:cs typeface="Vazirmatn" pitchFamily="34" charset="-120"/>
+                <a:latin typeface="Arial" pitchFamily="34" charset="0"/>
+                <a:cs typeface="Arial" pitchFamily="34" charset="178"/>
               </a:rPr>
               <a:t>اتفاق</a:t>
             </a:r>
@@ -12160,9 +11978,8 @@
                 <a:solidFill>
                   <a:schemeClr val="tx1"/>
                 </a:solidFill>
-                <a:latin typeface="Vazirmatn" pitchFamily="34" charset="0"/>
-                <a:ea typeface="Vazirmatn" pitchFamily="34" charset="-122"/>
-                <a:cs typeface="Vazirmatn" pitchFamily="34" charset="-120"/>
+                <a:latin typeface="Arial" pitchFamily="34" charset="0"/>
+                <a:cs typeface="Arial" pitchFamily="34" charset="178"/>
               </a:rPr>
               <a:t>خشم</a:t>
             </a:r>
@@ -12223,9 +12040,8 @@
                 <a:solidFill>
                   <a:schemeClr val="tx1"/>
                 </a:solidFill>
-                <a:latin typeface="Vazirmatn" pitchFamily="34" charset="0"/>
-                <a:ea typeface="Vazirmatn" pitchFamily="34" charset="-122"/>
-                <a:cs typeface="Vazirmatn" pitchFamily="34" charset="-120"/>
+                <a:latin typeface="Arial" pitchFamily="34" charset="0"/>
+                <a:cs typeface="Arial" pitchFamily="34" charset="178"/>
               </a:rPr>
               <a:t>نیاز / مرز</a:t>
             </a:r>
@@ -12286,9 +12102,8 @@
                 <a:solidFill>
                   <a:schemeClr val="accent2"/>
                 </a:solidFill>
-                <a:latin typeface="Vazirmatn" pitchFamily="34" charset="0"/>
-                <a:ea typeface="Vazirmatn" pitchFamily="34" charset="-122"/>
-                <a:cs typeface="Vazirmatn" pitchFamily="34" charset="-120"/>
+                <a:latin typeface="Arial" pitchFamily="34" charset="0"/>
+                <a:cs typeface="Arial" pitchFamily="34" charset="178"/>
               </a:rPr>
               <a:t>اقدام</a:t>
             </a:r>
@@ -12348,9 +12163,8 @@
                 <a:solidFill>
                   <a:schemeClr val="accent1"/>
                 </a:solidFill>
-                <a:latin typeface="Vazirmatn" pitchFamily="34" charset="0"/>
-                <a:ea typeface="Vazirmatn" pitchFamily="34" charset="-122"/>
-                <a:cs typeface="Vazirmatn" pitchFamily="34" charset="-120"/>
+                <a:latin typeface="Arial" pitchFamily="34" charset="0"/>
+                <a:cs typeface="Arial" pitchFamily="34" charset="178"/>
               </a:rPr>
               <a:t>مسیر دوم</a:t>
             </a:r>
@@ -12387,9 +12201,8 @@
                 <a:solidFill>
                   <a:schemeClr val="tx1"/>
                 </a:solidFill>
-                <a:latin typeface="Vazirmatn" pitchFamily="34" charset="0"/>
-                <a:ea typeface="Vazirmatn" pitchFamily="34" charset="-122"/>
-                <a:cs typeface="Vazirmatn" pitchFamily="34" charset="-120"/>
+                <a:latin typeface="Arial" pitchFamily="34" charset="0"/>
+                <a:cs typeface="Arial" pitchFamily="34" charset="178"/>
               </a:rPr>
               <a:t>اتفاق</a:t>
             </a:r>
@@ -12450,9 +12263,8 @@
                 <a:solidFill>
                   <a:schemeClr val="tx1"/>
                 </a:solidFill>
-                <a:latin typeface="Vazirmatn" pitchFamily="34" charset="0"/>
-                <a:ea typeface="Vazirmatn" pitchFamily="34" charset="-122"/>
-                <a:cs typeface="Vazirmatn" pitchFamily="34" charset="-120"/>
+                <a:latin typeface="Arial" pitchFamily="34" charset="0"/>
+                <a:cs typeface="Arial" pitchFamily="34" charset="178"/>
               </a:rPr>
               <a:t>شرم / ترس</a:t>
             </a:r>
@@ -12513,9 +12325,8 @@
                 <a:solidFill>
                   <a:schemeClr val="tx1"/>
                 </a:solidFill>
-                <a:latin typeface="Vazirmatn" pitchFamily="34" charset="0"/>
-                <a:ea typeface="Vazirmatn" pitchFamily="34" charset="-122"/>
-                <a:cs typeface="Vazirmatn" pitchFamily="34" charset="-120"/>
+                <a:latin typeface="Arial" pitchFamily="34" charset="0"/>
+                <a:cs typeface="Arial" pitchFamily="34" charset="178"/>
               </a:rPr>
               <a:t>خودسرزنشی</a:t>
             </a:r>
@@ -12576,9 +12387,8 @@
                 <a:solidFill>
                   <a:schemeClr val="tx1"/>
                 </a:solidFill>
-                <a:latin typeface="Vazirmatn" pitchFamily="34" charset="0"/>
-                <a:ea typeface="Vazirmatn" pitchFamily="34" charset="-122"/>
-                <a:cs typeface="Vazirmatn" pitchFamily="34" charset="-120"/>
+                <a:latin typeface="Arial" pitchFamily="34" charset="0"/>
+                <a:cs typeface="Arial" pitchFamily="34" charset="178"/>
               </a:rPr>
               <a:t>نشخوار</a:t>
             </a:r>
@@ -12639,9 +12449,8 @@
                 <a:solidFill>
                   <a:schemeClr val="accent1"/>
                 </a:solidFill>
-                <a:latin typeface="Vazirmatn" pitchFamily="34" charset="0"/>
-                <a:ea typeface="Vazirmatn" pitchFamily="34" charset="-122"/>
-                <a:cs typeface="Vazirmatn" pitchFamily="34" charset="-120"/>
+                <a:latin typeface="Arial" pitchFamily="34" charset="0"/>
+                <a:cs typeface="Arial" pitchFamily="34" charset="178"/>
               </a:rPr>
               <a:t>حمله به خود</a:t>
             </a:r>
@@ -12678,9 +12487,8 @@
                 <a:solidFill>
                   <a:schemeClr val="accent5"/>
                 </a:solidFill>
-                <a:latin typeface="Vazirmatn" pitchFamily="34" charset="0"/>
-                <a:ea typeface="Vazirmatn" pitchFamily="34" charset="-122"/>
-                <a:cs typeface="Vazirmatn" pitchFamily="34" charset="-120"/>
+                <a:latin typeface="Arial" pitchFamily="34" charset="0"/>
+                <a:cs typeface="Arial" pitchFamily="34" charset="178"/>
               </a:rPr>
               <a:t>چارچوب آموزشی وبینار؛ نه یک مدل واحد منتشرشده</a:t>
             </a:r>
@@ -12720,9 +12528,8 @@
                 <a:solidFill>
                   <a:schemeClr val="accent5"/>
                 </a:solidFill>
-                <a:latin typeface="Vazirmatn"/>
-                <a:ea typeface="Vazirmatn"/>
-                <a:cs typeface="Vazirmatn"/>
+                <a:latin typeface="Arial"/>
+                <a:cs typeface="Arial"/>
               </a:defRPr>
             </a:lvl1pPr>
           </a:lstStyle>
@@ -12790,9 +12597,8 @@
                 <a:solidFill>
                   <a:schemeClr val="accent1"/>
                 </a:solidFill>
-                <a:latin typeface="Vazirmatn" pitchFamily="34" charset="0"/>
-                <a:ea typeface="Vazirmatn" pitchFamily="34" charset="-122"/>
-                <a:cs typeface="Vazirmatn" pitchFamily="34" charset="-120"/>
+                <a:latin typeface="Arial" pitchFamily="34" charset="0"/>
+                <a:cs typeface="Arial" pitchFamily="34" charset="178"/>
               </a:rPr>
               <a:t>خشم</a:t>
             </a:r>
@@ -12829,9 +12635,8 @@
                 <a:solidFill>
                   <a:schemeClr val="accent6"/>
                 </a:solidFill>
-                <a:latin typeface="Vazirmatn" pitchFamily="34" charset="0"/>
-                <a:ea typeface="Vazirmatn" pitchFamily="34" charset="-122"/>
-                <a:cs typeface="Vazirmatn" pitchFamily="34" charset="-120"/>
+                <a:latin typeface="Arial" pitchFamily="34" charset="0"/>
+                <a:cs typeface="Arial" pitchFamily="34" charset="178"/>
               </a:rPr>
               <a:t>≠</a:t>
             </a:r>
@@ -12868,9 +12673,8 @@
                 <a:solidFill>
                   <a:schemeClr val="accent5"/>
                 </a:solidFill>
-                <a:latin typeface="Vazirmatn" pitchFamily="34" charset="0"/>
-                <a:ea typeface="Vazirmatn" pitchFamily="34" charset="-122"/>
-                <a:cs typeface="Vazirmatn" pitchFamily="34" charset="-120"/>
+                <a:latin typeface="Arial" pitchFamily="34" charset="0"/>
+                <a:cs typeface="Arial" pitchFamily="34" charset="178"/>
               </a:rPr>
               <a:t>پرخاشگری</a:t>
             </a:r>
@@ -12907,9 +12711,8 @@
                 <a:solidFill>
                   <a:schemeClr val="tx1"/>
                 </a:solidFill>
-                <a:latin typeface="Vazirmatn" pitchFamily="34" charset="0"/>
-                <a:ea typeface="Vazirmatn" pitchFamily="34" charset="-122"/>
-                <a:cs typeface="Vazirmatn" pitchFamily="34" charset="-120"/>
+                <a:latin typeface="Arial" pitchFamily="34" charset="0"/>
+                <a:cs typeface="Arial" pitchFamily="34" charset="178"/>
               </a:rPr>
               <a:t>خشم می‌تواند یک «اطلاعات» باشد.</a:t>
             </a:r>
@@ -12946,9 +12749,8 @@
                 <a:solidFill>
                   <a:schemeClr val="accent3"/>
                 </a:solidFill>
-                <a:latin typeface="Vazirmatn" pitchFamily="34" charset="0"/>
-                <a:ea typeface="Vazirmatn" pitchFamily="34" charset="-122"/>
-                <a:cs typeface="Vazirmatn" pitchFamily="34" charset="-120"/>
+                <a:latin typeface="Arial" pitchFamily="34" charset="0"/>
+                <a:cs typeface="Arial" pitchFamily="34" charset="178"/>
               </a:rPr>
               <a:t>ممکن است از یک مرز</a:t>
             </a:r>
@@ -12963,9 +12765,8 @@
                 <a:solidFill>
                   <a:schemeClr val="accent3"/>
                 </a:solidFill>
-                <a:latin typeface="Vazirmatn" pitchFamily="34" charset="0"/>
-                <a:ea typeface="Vazirmatn" pitchFamily="34" charset="-122"/>
-                <a:cs typeface="Vazirmatn" pitchFamily="34" charset="-120"/>
+                <a:latin typeface="Arial" pitchFamily="34" charset="0"/>
+                <a:cs typeface="Arial" pitchFamily="34" charset="178"/>
               </a:rPr>
               <a:t>خبر بدهد.</a:t>
             </a:r>
@@ -13002,9 +12803,8 @@
                 <a:solidFill>
                   <a:schemeClr val="accent3"/>
                 </a:solidFill>
-                <a:latin typeface="Vazirmatn" pitchFamily="34" charset="0"/>
-                <a:ea typeface="Vazirmatn" pitchFamily="34" charset="-122"/>
-                <a:cs typeface="Vazirmatn" pitchFamily="34" charset="-120"/>
+                <a:latin typeface="Arial" pitchFamily="34" charset="0"/>
+                <a:cs typeface="Arial" pitchFamily="34" charset="178"/>
               </a:rPr>
               <a:t>ممکن است یک نیاز</a:t>
             </a:r>
@@ -13019,9 +12819,8 @@
                 <a:solidFill>
                   <a:schemeClr val="accent3"/>
                 </a:solidFill>
-                <a:latin typeface="Vazirmatn" pitchFamily="34" charset="0"/>
-                <a:ea typeface="Vazirmatn" pitchFamily="34" charset="-122"/>
-                <a:cs typeface="Vazirmatn" pitchFamily="34" charset="-120"/>
+                <a:latin typeface="Arial" pitchFamily="34" charset="0"/>
+                <a:cs typeface="Arial" pitchFamily="34" charset="178"/>
               </a:rPr>
               <a:t>مهم را نشان دهد.</a:t>
             </a:r>
@@ -13058,9 +12857,8 @@
                 <a:solidFill>
                   <a:schemeClr val="accent3"/>
                 </a:solidFill>
-                <a:latin typeface="Vazirmatn" pitchFamily="34" charset="0"/>
-                <a:ea typeface="Vazirmatn" pitchFamily="34" charset="-122"/>
-                <a:cs typeface="Vazirmatn" pitchFamily="34" charset="-120"/>
+                <a:latin typeface="Arial" pitchFamily="34" charset="0"/>
+                <a:cs typeface="Arial" pitchFamily="34" charset="178"/>
               </a:rPr>
               <a:t>ممکن است ما را به سمت</a:t>
             </a:r>
@@ -13075,9 +12873,8 @@
                 <a:solidFill>
                   <a:schemeClr val="accent3"/>
                 </a:solidFill>
-                <a:latin typeface="Vazirmatn" pitchFamily="34" charset="0"/>
-                <a:ea typeface="Vazirmatn" pitchFamily="34" charset="-122"/>
-                <a:cs typeface="Vazirmatn" pitchFamily="34" charset="-120"/>
+                <a:latin typeface="Arial" pitchFamily="34" charset="0"/>
+                <a:cs typeface="Arial" pitchFamily="34" charset="178"/>
               </a:rPr>
               <a:t>اقدام هدایت کند.</a:t>
             </a:r>
@@ -13114,9 +12911,8 @@
                 <a:solidFill>
                   <a:schemeClr val="accent5"/>
                 </a:solidFill>
-                <a:latin typeface="Vazirmatn" pitchFamily="34" charset="0"/>
-                <a:ea typeface="Vazirmatn" pitchFamily="34" charset="-122"/>
-                <a:cs typeface="Vazirmatn" pitchFamily="34" charset="-120"/>
+                <a:latin typeface="Arial" pitchFamily="34" charset="0"/>
+                <a:cs typeface="Arial" pitchFamily="34" charset="178"/>
               </a:rPr>
               <a:t>اما خشم به‌خودی‌خود مجوز رفتار آسیب‌زننده نیست.</a:t>
             </a:r>
@@ -13156,9 +12952,8 @@
                 <a:solidFill>
                   <a:schemeClr val="accent5"/>
                 </a:solidFill>
-                <a:latin typeface="Vazirmatn"/>
-                <a:ea typeface="Vazirmatn"/>
-                <a:cs typeface="Vazirmatn"/>
+                <a:latin typeface="Arial"/>
+                <a:cs typeface="Arial"/>
               </a:defRPr>
             </a:lvl1pPr>
           </a:lstStyle>
@@ -13228,9 +13023,8 @@
                 <a:solidFill>
                   <a:schemeClr val="tx2"/>
                 </a:solidFill>
-                <a:latin typeface="Vazirmatn" pitchFamily="34" charset="0"/>
-                <a:ea typeface="Vazirmatn" pitchFamily="34" charset="-122"/>
-                <a:cs typeface="Vazirmatn" pitchFamily="34" charset="-120"/>
+                <a:latin typeface="Arial" pitchFamily="34" charset="0"/>
+                <a:cs typeface="Arial" pitchFamily="34" charset="178"/>
               </a:rPr>
               <a:t>سه پژوهش؛ سه قطعه از یک پازل</a:t>
             </a:r>
@@ -13294,9 +13088,8 @@
                 <a:solidFill>
                   <a:schemeClr val="accent1"/>
                 </a:solidFill>
-                <a:latin typeface="Vazirmatn" pitchFamily="34" charset="0"/>
-                <a:ea typeface="Vazirmatn" pitchFamily="34" charset="-122"/>
-                <a:cs typeface="Vazirmatn" pitchFamily="34" charset="-120"/>
+                <a:latin typeface="Arial" pitchFamily="34" charset="0"/>
+                <a:cs typeface="Arial" pitchFamily="34" charset="178"/>
               </a:rPr>
               <a:t>۲۰۲۵</a:t>
             </a:r>
@@ -13333,9 +13126,8 @@
                 <a:solidFill>
                   <a:schemeClr val="accent5"/>
                 </a:solidFill>
-                <a:latin typeface="Vazirmatn" pitchFamily="34" charset="0"/>
-                <a:ea typeface="Vazirmatn" pitchFamily="34" charset="-122"/>
-                <a:cs typeface="Vazirmatn" pitchFamily="34" charset="-120"/>
+                <a:latin typeface="Arial" pitchFamily="34" charset="0"/>
+                <a:cs typeface="Arial" pitchFamily="34" charset="178"/>
               </a:rPr>
               <a:t>BMC Psychology</a:t>
             </a:r>
@@ -13372,9 +13164,8 @@
                 <a:solidFill>
                   <a:schemeClr val="tx1"/>
                 </a:solidFill>
-                <a:latin typeface="Vazirmatn" pitchFamily="34" charset="0"/>
-                <a:ea typeface="Vazirmatn" pitchFamily="34" charset="-122"/>
-                <a:cs typeface="Vazirmatn" pitchFamily="34" charset="-120"/>
+                <a:latin typeface="Arial" pitchFamily="34" charset="0"/>
+                <a:cs typeface="Arial" pitchFamily="34" charset="178"/>
               </a:rPr>
               <a:t>Šoková et al.</a:t>
             </a:r>
@@ -13411,9 +13202,8 @@
                 <a:solidFill>
                   <a:schemeClr val="accent2"/>
                 </a:solidFill>
-                <a:latin typeface="Vazirmatn" pitchFamily="34" charset="0"/>
-                <a:ea typeface="Vazirmatn" pitchFamily="34" charset="-122"/>
-                <a:cs typeface="Vazirmatn" pitchFamily="34" charset="-120"/>
+                <a:latin typeface="Arial" pitchFamily="34" charset="0"/>
+                <a:cs typeface="Arial" pitchFamily="34" charset="178"/>
               </a:rPr>
               <a:t>Inner Critic</a:t>
             </a:r>
@@ -13428,9 +13218,8 @@
                 <a:solidFill>
                   <a:schemeClr val="accent2"/>
                 </a:solidFill>
-                <a:latin typeface="Vazirmatn" pitchFamily="34" charset="0"/>
-                <a:ea typeface="Vazirmatn" pitchFamily="34" charset="-122"/>
-                <a:cs typeface="Vazirmatn" pitchFamily="34" charset="-120"/>
+                <a:latin typeface="Arial" pitchFamily="34" charset="0"/>
+                <a:cs typeface="Arial" pitchFamily="34" charset="178"/>
               </a:rPr>
               <a:t>Self-Criticism</a:t>
             </a:r>
@@ -13467,9 +13256,8 @@
                 <a:solidFill>
                   <a:schemeClr val="accent5"/>
                 </a:solidFill>
-                <a:latin typeface="Vazirmatn" pitchFamily="34" charset="0"/>
-                <a:ea typeface="Vazirmatn" pitchFamily="34" charset="-122"/>
-                <a:cs typeface="Vazirmatn" pitchFamily="34" charset="-120"/>
+                <a:latin typeface="Arial" pitchFamily="34" charset="0"/>
+                <a:cs typeface="Arial" pitchFamily="34" charset="178"/>
               </a:rPr>
               <a:t>پژوهش کیفی</a:t>
             </a:r>
@@ -13533,9 +13321,8 @@
                 <a:solidFill>
                   <a:schemeClr val="accent1"/>
                 </a:solidFill>
-                <a:latin typeface="Vazirmatn" pitchFamily="34" charset="0"/>
-                <a:ea typeface="Vazirmatn" pitchFamily="34" charset="-122"/>
-                <a:cs typeface="Vazirmatn" pitchFamily="34" charset="-120"/>
+                <a:latin typeface="Arial" pitchFamily="34" charset="0"/>
+                <a:cs typeface="Arial" pitchFamily="34" charset="178"/>
               </a:rPr>
               <a:t>۲۰۲۶</a:t>
             </a:r>
@@ -13572,9 +13359,8 @@
                 <a:solidFill>
                   <a:schemeClr val="accent5"/>
                 </a:solidFill>
-                <a:latin typeface="Vazirmatn" pitchFamily="34" charset="0"/>
-                <a:ea typeface="Vazirmatn" pitchFamily="34" charset="-122"/>
-                <a:cs typeface="Vazirmatn" pitchFamily="34" charset="-120"/>
+                <a:latin typeface="Arial" pitchFamily="34" charset="0"/>
+                <a:cs typeface="Arial" pitchFamily="34" charset="178"/>
               </a:rPr>
               <a:t>Frontiers in Psychiatry</a:t>
             </a:r>
@@ -13611,9 +13397,8 @@
                 <a:solidFill>
                   <a:schemeClr val="tx1"/>
                 </a:solidFill>
-                <a:latin typeface="Vazirmatn" pitchFamily="34" charset="0"/>
-                <a:ea typeface="Vazirmatn" pitchFamily="34" charset="-122"/>
-                <a:cs typeface="Vazirmatn" pitchFamily="34" charset="-120"/>
+                <a:latin typeface="Arial" pitchFamily="34" charset="0"/>
+                <a:cs typeface="Arial" pitchFamily="34" charset="178"/>
               </a:rPr>
               <a:t>Oblak et al.</a:t>
             </a:r>
@@ -13650,9 +13435,8 @@
                 <a:solidFill>
                   <a:schemeClr val="accent2"/>
                 </a:solidFill>
-                <a:latin typeface="Vazirmatn" pitchFamily="34" charset="0"/>
-                <a:ea typeface="Vazirmatn" pitchFamily="34" charset="-122"/>
-                <a:cs typeface="Vazirmatn" pitchFamily="34" charset="-120"/>
+                <a:latin typeface="Arial" pitchFamily="34" charset="0"/>
+                <a:cs typeface="Arial" pitchFamily="34" charset="178"/>
               </a:rPr>
               <a:t>Rumination</a:t>
             </a:r>
@@ -13689,9 +13473,8 @@
                 <a:solidFill>
                   <a:schemeClr val="accent5"/>
                 </a:solidFill>
-                <a:latin typeface="Vazirmatn" pitchFamily="34" charset="0"/>
-                <a:ea typeface="Vazirmatn" pitchFamily="34" charset="-122"/>
-                <a:cs typeface="Vazirmatn" pitchFamily="34" charset="-120"/>
+                <a:latin typeface="Arial" pitchFamily="34" charset="0"/>
+                <a:cs typeface="Arial" pitchFamily="34" charset="178"/>
               </a:rPr>
               <a:t>پژوهش پدیدارشناختی</a:t>
             </a:r>
@@ -13755,9 +13538,8 @@
                 <a:solidFill>
                   <a:schemeClr val="accent1"/>
                 </a:solidFill>
-                <a:latin typeface="Vazirmatn" pitchFamily="34" charset="0"/>
-                <a:ea typeface="Vazirmatn" pitchFamily="34" charset="-122"/>
-                <a:cs typeface="Vazirmatn" pitchFamily="34" charset="-120"/>
+                <a:latin typeface="Arial" pitchFamily="34" charset="0"/>
+                <a:cs typeface="Arial" pitchFamily="34" charset="178"/>
               </a:rPr>
               <a:t>۲۰۲۴</a:t>
             </a:r>
@@ -13794,9 +13576,8 @@
                 <a:solidFill>
                   <a:schemeClr val="accent5"/>
                 </a:solidFill>
-                <a:latin typeface="Vazirmatn" pitchFamily="34" charset="0"/>
-                <a:ea typeface="Vazirmatn" pitchFamily="34" charset="-122"/>
-                <a:cs typeface="Vazirmatn" pitchFamily="34" charset="-120"/>
+                <a:latin typeface="Arial" pitchFamily="34" charset="0"/>
+                <a:cs typeface="Arial" pitchFamily="34" charset="178"/>
               </a:rPr>
               <a:t>Frontiers in Psychology</a:t>
             </a:r>
@@ -13833,9 +13614,8 @@
                 <a:solidFill>
                   <a:schemeClr val="tx1"/>
                 </a:solidFill>
-                <a:latin typeface="Vazirmatn" pitchFamily="34" charset="0"/>
-                <a:ea typeface="Vazirmatn" pitchFamily="34" charset="-122"/>
-                <a:cs typeface="Vazirmatn" pitchFamily="34" charset="-120"/>
+                <a:latin typeface="Arial" pitchFamily="34" charset="0"/>
+                <a:cs typeface="Arial" pitchFamily="34" charset="178"/>
               </a:rPr>
               <a:t>Khan, Rehna &amp; Butt</a:t>
             </a:r>
@@ -13872,9 +13652,8 @@
                 <a:solidFill>
                   <a:schemeClr val="accent2"/>
                 </a:solidFill>
-                <a:latin typeface="Vazirmatn" pitchFamily="34" charset="0"/>
-                <a:ea typeface="Vazirmatn" pitchFamily="34" charset="-122"/>
-                <a:cs typeface="Vazirmatn" pitchFamily="34" charset="-120"/>
+                <a:latin typeface="Arial" pitchFamily="34" charset="0"/>
+                <a:cs typeface="Arial" pitchFamily="34" charset="178"/>
               </a:rPr>
               <a:t>Rumination</a:t>
             </a:r>
@@ -13889,9 +13668,8 @@
                 <a:solidFill>
                   <a:schemeClr val="accent2"/>
                 </a:solidFill>
-                <a:latin typeface="Vazirmatn" pitchFamily="34" charset="0"/>
-                <a:ea typeface="Vazirmatn" pitchFamily="34" charset="-122"/>
-                <a:cs typeface="Vazirmatn" pitchFamily="34" charset="-120"/>
+                <a:latin typeface="Arial" pitchFamily="34" charset="0"/>
+                <a:cs typeface="Arial" pitchFamily="34" charset="178"/>
               </a:rPr>
               <a:t>Emotional Turbulence</a:t>
             </a:r>
@@ -13928,9 +13706,8 @@
                 <a:solidFill>
                   <a:schemeClr val="accent5"/>
                 </a:solidFill>
-                <a:latin typeface="Vazirmatn" pitchFamily="34" charset="0"/>
-                <a:ea typeface="Vazirmatn" pitchFamily="34" charset="-122"/>
-                <a:cs typeface="Vazirmatn" pitchFamily="34" charset="-120"/>
+                <a:latin typeface="Arial" pitchFamily="34" charset="0"/>
+                <a:cs typeface="Arial" pitchFamily="34" charset="178"/>
               </a:rPr>
               <a:t>در افراد دارای NSSI</a:t>
             </a:r>
@@ -13967,9 +13744,8 @@
                 <a:solidFill>
                   <a:schemeClr val="accent5"/>
                 </a:solidFill>
-                <a:latin typeface="Vazirmatn" pitchFamily="34" charset="0"/>
-                <a:ea typeface="Vazirmatn" pitchFamily="34" charset="-122"/>
-                <a:cs typeface="Vazirmatn" pitchFamily="34" charset="-120"/>
+                <a:latin typeface="Arial" pitchFamily="34" charset="0"/>
+                <a:cs typeface="Arial" pitchFamily="34" charset="178"/>
               </a:rPr>
               <a:t>هر مقاله یک بخش از تجربه را روشن می‌کند؛ نه کل پدیده را.</a:t>
             </a:r>
@@ -14009,9 +13785,8 @@
                 <a:solidFill>
                   <a:schemeClr val="accent5"/>
                 </a:solidFill>
-                <a:latin typeface="Vazirmatn"/>
-                <a:ea typeface="Vazirmatn"/>
-                <a:cs typeface="Vazirmatn"/>
+                <a:latin typeface="Arial"/>
+                <a:cs typeface="Arial"/>
               </a:defRPr>
             </a:lvl1pPr>
           </a:lstStyle>
@@ -14081,9 +13856,8 @@
                 <a:solidFill>
                   <a:schemeClr val="tx2"/>
                 </a:solidFill>
-                <a:latin typeface="Vazirmatn" pitchFamily="34" charset="0"/>
-                <a:ea typeface="Vazirmatn" pitchFamily="34" charset="-122"/>
-                <a:cs typeface="Vazirmatn" pitchFamily="34" charset="-120"/>
+                <a:latin typeface="Arial" pitchFamily="34" charset="0"/>
+                <a:cs typeface="Arial" pitchFamily="34" charset="178"/>
               </a:rPr>
               <a:t>منتقد درونی فقط یک صدا نیست</a:t>
             </a:r>
@@ -14147,9 +13921,8 @@
                 <a:solidFill>
                   <a:schemeClr val="accent2"/>
                 </a:solidFill>
-                <a:latin typeface="Vazirmatn" pitchFamily="34" charset="0"/>
-                <a:ea typeface="Vazirmatn" pitchFamily="34" charset="-122"/>
-                <a:cs typeface="Vazirmatn" pitchFamily="34" charset="-120"/>
+                <a:latin typeface="Arial" pitchFamily="34" charset="0"/>
+                <a:cs typeface="Arial" pitchFamily="34" charset="178"/>
               </a:rPr>
               <a:t>Worrier</a:t>
             </a:r>
@@ -14189,9 +13962,8 @@
                 <a:solidFill>
                   <a:schemeClr val="tx1"/>
                 </a:solidFill>
-                <a:latin typeface="Vazirmatn" pitchFamily="34" charset="0"/>
-                <a:ea typeface="Vazirmatn" pitchFamily="34" charset="-122"/>
-                <a:cs typeface="Vazirmatn" pitchFamily="34" charset="-120"/>
+                <a:latin typeface="Arial" pitchFamily="34" charset="0"/>
+                <a:cs typeface="Arial" pitchFamily="34" charset="178"/>
               </a:rPr>
               <a:t>«مواظب باش؛ دوباره خراب می‌شود.»</a:t>
             </a:r>
@@ -14255,9 +14027,8 @@
                 <a:solidFill>
                   <a:schemeClr val="accent2"/>
                 </a:solidFill>
-                <a:latin typeface="Vazirmatn" pitchFamily="34" charset="0"/>
-                <a:ea typeface="Vazirmatn" pitchFamily="34" charset="-122"/>
-                <a:cs typeface="Vazirmatn" pitchFamily="34" charset="-120"/>
+                <a:latin typeface="Arial" pitchFamily="34" charset="0"/>
+                <a:cs typeface="Arial" pitchFamily="34" charset="178"/>
               </a:rPr>
               <a:t>Not good enough</a:t>
             </a:r>
@@ -14297,9 +14068,8 @@
                 <a:solidFill>
                   <a:schemeClr val="tx1"/>
                 </a:solidFill>
-                <a:latin typeface="Vazirmatn" pitchFamily="34" charset="0"/>
-                <a:ea typeface="Vazirmatn" pitchFamily="34" charset="-122"/>
-                <a:cs typeface="Vazirmatn" pitchFamily="34" charset="-120"/>
+                <a:latin typeface="Arial" pitchFamily="34" charset="0"/>
+                <a:cs typeface="Arial" pitchFamily="34" charset="178"/>
               </a:rPr>
               <a:t>«به اندازه کافی خوب نیستی.»</a:t>
             </a:r>
@@ -14363,9 +14133,8 @@
                 <a:solidFill>
                   <a:schemeClr val="accent2"/>
                 </a:solidFill>
-                <a:latin typeface="Vazirmatn" pitchFamily="34" charset="0"/>
-                <a:ea typeface="Vazirmatn" pitchFamily="34" charset="-122"/>
-                <a:cs typeface="Vazirmatn" pitchFamily="34" charset="-120"/>
+                <a:latin typeface="Arial" pitchFamily="34" charset="0"/>
+                <a:cs typeface="Arial" pitchFamily="34" charset="178"/>
               </a:rPr>
               <a:t>Hated self</a:t>
             </a:r>
@@ -14405,9 +14174,8 @@
                 <a:solidFill>
                   <a:schemeClr val="tx1"/>
                 </a:solidFill>
-                <a:latin typeface="Vazirmatn" pitchFamily="34" charset="0"/>
-                <a:ea typeface="Vazirmatn" pitchFamily="34" charset="-122"/>
-                <a:cs typeface="Vazirmatn" pitchFamily="34" charset="-120"/>
+                <a:latin typeface="Arial" pitchFamily="34" charset="0"/>
+                <a:cs typeface="Arial" pitchFamily="34" charset="178"/>
               </a:rPr>
               <a:t>«خودت مشکل هستی.»</a:t>
             </a:r>
@@ -14471,9 +14239,8 @@
                 <a:solidFill>
                   <a:schemeClr val="accent2"/>
                 </a:solidFill>
-                <a:latin typeface="Vazirmatn" pitchFamily="34" charset="0"/>
-                <a:ea typeface="Vazirmatn" pitchFamily="34" charset="-122"/>
-                <a:cs typeface="Vazirmatn" pitchFamily="34" charset="-120"/>
+                <a:latin typeface="Arial" pitchFamily="34" charset="0"/>
+                <a:cs typeface="Arial" pitchFamily="34" charset="178"/>
               </a:rPr>
               <a:t>Teamster</a:t>
             </a:r>
@@ -14513,9 +14280,8 @@
                 <a:solidFill>
                   <a:schemeClr val="tx1"/>
                 </a:solidFill>
-                <a:latin typeface="Vazirmatn" pitchFamily="34" charset="0"/>
-                <a:ea typeface="Vazirmatn" pitchFamily="34" charset="-122"/>
-                <a:cs typeface="Vazirmatn" pitchFamily="34" charset="-120"/>
+                <a:latin typeface="Arial" pitchFamily="34" charset="0"/>
+                <a:cs typeface="Arial" pitchFamily="34" charset="178"/>
               </a:rPr>
               <a:t>«باید بیشتر تلاش کنی.»</a:t>
             </a:r>
@@ -14579,9 +14345,8 @@
                 <a:solidFill>
                   <a:schemeClr val="accent2"/>
                 </a:solidFill>
-                <a:latin typeface="Vazirmatn" pitchFamily="34" charset="0"/>
-                <a:ea typeface="Vazirmatn" pitchFamily="34" charset="-122"/>
-                <a:cs typeface="Vazirmatn" pitchFamily="34" charset="-120"/>
+                <a:latin typeface="Arial" pitchFamily="34" charset="0"/>
+                <a:cs typeface="Arial" pitchFamily="34" charset="178"/>
               </a:rPr>
               <a:t>Non-feeler</a:t>
             </a:r>
@@ -14621,9 +14386,8 @@
                 <a:solidFill>
                   <a:schemeClr val="tx1"/>
                 </a:solidFill>
-                <a:latin typeface="Vazirmatn" pitchFamily="34" charset="0"/>
-                <a:ea typeface="Vazirmatn" pitchFamily="34" charset="-122"/>
-                <a:cs typeface="Vazirmatn" pitchFamily="34" charset="-120"/>
+                <a:latin typeface="Arial" pitchFamily="34" charset="0"/>
+                <a:cs typeface="Arial" pitchFamily="34" charset="178"/>
               </a:rPr>
               <a:t>«احساس نکن؛ کنترلش کن.»</a:t>
             </a:r>
@@ -14687,9 +14451,8 @@
                 <a:solidFill>
                   <a:schemeClr val="accent2"/>
                 </a:solidFill>
-                <a:latin typeface="Vazirmatn" pitchFamily="34" charset="0"/>
-                <a:ea typeface="Vazirmatn" pitchFamily="34" charset="-122"/>
-                <a:cs typeface="Vazirmatn" pitchFamily="34" charset="-120"/>
+                <a:latin typeface="Arial" pitchFamily="34" charset="0"/>
+                <a:cs typeface="Arial" pitchFamily="34" charset="178"/>
               </a:rPr>
               <a:t>Not good enough for others</a:t>
             </a:r>
@@ -14729,9 +14492,8 @@
                 <a:solidFill>
                   <a:schemeClr val="tx1"/>
                 </a:solidFill>
-                <a:latin typeface="Vazirmatn" pitchFamily="34" charset="0"/>
-                <a:ea typeface="Vazirmatn" pitchFamily="34" charset="-122"/>
-                <a:cs typeface="Vazirmatn" pitchFamily="34" charset="-120"/>
+                <a:latin typeface="Arial" pitchFamily="34" charset="0"/>
+                <a:cs typeface="Arial" pitchFamily="34" charset="178"/>
               </a:rPr>
               <a:t>«باید از نگاه دیگران بهتر باشی.»</a:t>
             </a:r>
@@ -14768,9 +14530,8 @@
                 <a:solidFill>
                   <a:schemeClr val="accent5"/>
                 </a:solidFill>
-                <a:latin typeface="Vazirmatn" pitchFamily="34" charset="0"/>
-                <a:ea typeface="Vazirmatn" pitchFamily="34" charset="-122"/>
-                <a:cs typeface="Vazirmatn" pitchFamily="34" charset="-120"/>
+                <a:latin typeface="Arial" pitchFamily="34" charset="0"/>
+                <a:cs typeface="Arial" pitchFamily="34" charset="178"/>
               </a:rPr>
               <a:t>Šoková et al., 2025</a:t>
             </a:r>
@@ -14810,9 +14571,8 @@
                 <a:solidFill>
                   <a:schemeClr val="accent5"/>
                 </a:solidFill>
-                <a:latin typeface="Vazirmatn"/>
-                <a:ea typeface="Vazirmatn"/>
-                <a:cs typeface="Vazirmatn"/>
+                <a:latin typeface="Arial"/>
+                <a:cs typeface="Arial"/>
               </a:defRPr>
             </a:lvl1pPr>
           </a:lstStyle>
@@ -14882,9 +14642,8 @@
                 <a:solidFill>
                   <a:schemeClr val="tx2"/>
                 </a:solidFill>
-                <a:latin typeface="Vazirmatn" pitchFamily="34" charset="0"/>
-                <a:ea typeface="Vazirmatn" pitchFamily="34" charset="-122"/>
-                <a:cs typeface="Vazirmatn" pitchFamily="34" charset="-120"/>
+                <a:latin typeface="Arial" pitchFamily="34" charset="0"/>
+                <a:cs typeface="Arial" pitchFamily="34" charset="178"/>
               </a:rPr>
               <a:t>کدام صدای درونی برای شما آشناتر است؟</a:t>
             </a:r>
@@ -14946,9 +14705,8 @@
                 <a:solidFill>
                   <a:schemeClr val="accent2"/>
                 </a:solidFill>
-                <a:latin typeface="Vazirmatn" pitchFamily="34" charset="0"/>
-                <a:ea typeface="Vazirmatn" pitchFamily="34" charset="-122"/>
-                <a:cs typeface="Vazirmatn" pitchFamily="34" charset="-120"/>
+                <a:latin typeface="Arial" pitchFamily="34" charset="0"/>
+                <a:cs typeface="Arial" pitchFamily="34" charset="178"/>
               </a:rPr>
               <a:t>۱</a:t>
             </a:r>
@@ -14985,9 +14743,8 @@
                 <a:solidFill>
                   <a:schemeClr val="tx1"/>
                 </a:solidFill>
-                <a:latin typeface="Vazirmatn" pitchFamily="34" charset="0"/>
-                <a:ea typeface="Vazirmatn" pitchFamily="34" charset="-122"/>
-                <a:cs typeface="Vazirmatn" pitchFamily="34" charset="-120"/>
+                <a:latin typeface="Arial" pitchFamily="34" charset="0"/>
+                <a:cs typeface="Arial" pitchFamily="34" charset="178"/>
               </a:rPr>
               <a:t>«باید بهتر عمل می‌کردی.»</a:t>
             </a:r>
@@ -15049,9 +14806,8 @@
                 <a:solidFill>
                   <a:schemeClr val="accent2"/>
                 </a:solidFill>
-                <a:latin typeface="Vazirmatn" pitchFamily="34" charset="0"/>
-                <a:ea typeface="Vazirmatn" pitchFamily="34" charset="-122"/>
-                <a:cs typeface="Vazirmatn" pitchFamily="34" charset="-120"/>
+                <a:latin typeface="Arial" pitchFamily="34" charset="0"/>
+                <a:cs typeface="Arial" pitchFamily="34" charset="178"/>
               </a:rPr>
               <a:t>۲</a:t>
             </a:r>
@@ -15088,9 +14844,8 @@
                 <a:solidFill>
                   <a:schemeClr val="tx1"/>
                 </a:solidFill>
-                <a:latin typeface="Vazirmatn" pitchFamily="34" charset="0"/>
-                <a:ea typeface="Vazirmatn" pitchFamily="34" charset="-122"/>
-                <a:cs typeface="Vazirmatn" pitchFamily="34" charset="-120"/>
+                <a:latin typeface="Arial" pitchFamily="34" charset="0"/>
+                <a:cs typeface="Arial" pitchFamily="34" charset="178"/>
               </a:rPr>
               <a:t>«حواست باشد، دوباره خراب می‌شود.»</a:t>
             </a:r>
@@ -15152,9 +14907,8 @@
                 <a:solidFill>
                   <a:schemeClr val="accent2"/>
                 </a:solidFill>
-                <a:latin typeface="Vazirmatn" pitchFamily="34" charset="0"/>
-                <a:ea typeface="Vazirmatn" pitchFamily="34" charset="-122"/>
-                <a:cs typeface="Vazirmatn" pitchFamily="34" charset="-120"/>
+                <a:latin typeface="Arial" pitchFamily="34" charset="0"/>
+                <a:cs typeface="Arial" pitchFamily="34" charset="178"/>
               </a:rPr>
               <a:t>۳</a:t>
             </a:r>
@@ -15191,9 +14945,8 @@
                 <a:solidFill>
                   <a:schemeClr val="tx1"/>
                 </a:solidFill>
-                <a:latin typeface="Vazirmatn" pitchFamily="34" charset="0"/>
-                <a:ea typeface="Vazirmatn" pitchFamily="34" charset="-122"/>
-                <a:cs typeface="Vazirmatn" pitchFamily="34" charset="-120"/>
+                <a:latin typeface="Arial" pitchFamily="34" charset="0"/>
+                <a:cs typeface="Arial" pitchFamily="34" charset="178"/>
               </a:rPr>
               <a:t>«تو کافی نیستی.»</a:t>
             </a:r>
@@ -15255,9 +15008,8 @@
                 <a:solidFill>
                   <a:schemeClr val="accent2"/>
                 </a:solidFill>
-                <a:latin typeface="Vazirmatn" pitchFamily="34" charset="0"/>
-                <a:ea typeface="Vazirmatn" pitchFamily="34" charset="-122"/>
-                <a:cs typeface="Vazirmatn" pitchFamily="34" charset="-120"/>
+                <a:latin typeface="Arial" pitchFamily="34" charset="0"/>
+                <a:cs typeface="Arial" pitchFamily="34" charset="178"/>
               </a:rPr>
               <a:t>۴</a:t>
             </a:r>
@@ -15294,9 +15046,8 @@
                 <a:solidFill>
                   <a:schemeClr val="tx1"/>
                 </a:solidFill>
-                <a:latin typeface="Vazirmatn" pitchFamily="34" charset="0"/>
-                <a:ea typeface="Vazirmatn" pitchFamily="34" charset="-122"/>
-                <a:cs typeface="Vazirmatn" pitchFamily="34" charset="-120"/>
+                <a:latin typeface="Arial" pitchFamily="34" charset="0"/>
+                <a:cs typeface="Arial" pitchFamily="34" charset="178"/>
               </a:rPr>
               <a:t>«دیگران درباره‌ات چه فکر می‌کنند؟»</a:t>
             </a:r>
@@ -15358,9 +15109,8 @@
                 <a:solidFill>
                   <a:schemeClr val="accent2"/>
                 </a:solidFill>
-                <a:latin typeface="Vazirmatn" pitchFamily="34" charset="0"/>
-                <a:ea typeface="Vazirmatn" pitchFamily="34" charset="-122"/>
-                <a:cs typeface="Vazirmatn" pitchFamily="34" charset="-120"/>
+                <a:latin typeface="Arial" pitchFamily="34" charset="0"/>
+                <a:cs typeface="Arial" pitchFamily="34" charset="178"/>
               </a:rPr>
               <a:t>۵</a:t>
             </a:r>
@@ -15397,9 +15147,8 @@
                 <a:solidFill>
                   <a:schemeClr val="tx1"/>
                 </a:solidFill>
-                <a:latin typeface="Vazirmatn" pitchFamily="34" charset="0"/>
-                <a:ea typeface="Vazirmatn" pitchFamily="34" charset="-122"/>
-                <a:cs typeface="Vazirmatn" pitchFamily="34" charset="-120"/>
+                <a:latin typeface="Arial" pitchFamily="34" charset="0"/>
+                <a:cs typeface="Arial" pitchFamily="34" charset="178"/>
               </a:rPr>
               <a:t>«اصلاً احساساتی نشو.»</a:t>
             </a:r>
@@ -15461,9 +15210,8 @@
                 <a:solidFill>
                   <a:schemeClr val="accent2"/>
                 </a:solidFill>
-                <a:latin typeface="Vazirmatn" pitchFamily="34" charset="0"/>
-                <a:ea typeface="Vazirmatn" pitchFamily="34" charset="-122"/>
-                <a:cs typeface="Vazirmatn" pitchFamily="34" charset="-120"/>
+                <a:latin typeface="Arial" pitchFamily="34" charset="0"/>
+                <a:cs typeface="Arial" pitchFamily="34" charset="178"/>
               </a:rPr>
               <a:t>۶</a:t>
             </a:r>
@@ -15500,9 +15248,8 @@
                 <a:solidFill>
                   <a:schemeClr val="tx1"/>
                 </a:solidFill>
-                <a:latin typeface="Vazirmatn" pitchFamily="34" charset="0"/>
-                <a:ea typeface="Vazirmatn" pitchFamily="34" charset="-122"/>
-                <a:cs typeface="Vazirmatn" pitchFamily="34" charset="-120"/>
+                <a:latin typeface="Arial" pitchFamily="34" charset="0"/>
+                <a:cs typeface="Arial" pitchFamily="34" charset="178"/>
               </a:rPr>
               <a:t>«مشکل خودت هستی.»</a:t>
             </a:r>
@@ -15539,9 +15286,8 @@
                 <a:solidFill>
                   <a:schemeClr val="accent1"/>
                 </a:solidFill>
-                <a:latin typeface="Vazirmatn" pitchFamily="34" charset="0"/>
-                <a:ea typeface="Vazirmatn" pitchFamily="34" charset="-122"/>
-                <a:cs typeface="Vazirmatn" pitchFamily="34" charset="-120"/>
+                <a:latin typeface="Arial" pitchFamily="34" charset="0"/>
+                <a:cs typeface="Arial" pitchFamily="34" charset="178"/>
               </a:rPr>
               <a:t>در چت فقط یکی را انتخاب کنید.</a:t>
             </a:r>
@@ -15581,9 +15327,8 @@
                 <a:solidFill>
                   <a:schemeClr val="accent5"/>
                 </a:solidFill>
-                <a:latin typeface="Vazirmatn"/>
-                <a:ea typeface="Vazirmatn"/>
-                <a:cs typeface="Vazirmatn"/>
+                <a:latin typeface="Arial"/>
+                <a:cs typeface="Arial"/>
               </a:defRPr>
             </a:lvl1pPr>
           </a:lstStyle>
@@ -15653,9 +15398,8 @@
                 <a:solidFill>
                   <a:schemeClr val="tx2"/>
                 </a:solidFill>
-                <a:latin typeface="Vazirmatn" pitchFamily="34" charset="0"/>
-                <a:ea typeface="Vazirmatn" pitchFamily="34" charset="-122"/>
-                <a:cs typeface="Vazirmatn" pitchFamily="34" charset="-120"/>
+                <a:latin typeface="Arial" pitchFamily="34" charset="0"/>
+                <a:cs typeface="Arial" pitchFamily="34" charset="178"/>
               </a:rPr>
               <a:t>وقتی منتقد درونی فعال می‌شود چه اتفاقی می‌افتد؟</a:t>
             </a:r>
@@ -15692,9 +15436,8 @@
                 <a:solidFill>
                   <a:schemeClr val="accent1"/>
                 </a:solidFill>
-                <a:latin typeface="Vazirmatn" pitchFamily="34" charset="0"/>
-                <a:ea typeface="Vazirmatn" pitchFamily="34" charset="-122"/>
-                <a:cs typeface="Vazirmatn" pitchFamily="34" charset="-120"/>
+                <a:latin typeface="Arial" pitchFamily="34" charset="0"/>
+                <a:cs typeface="Arial" pitchFamily="34" charset="178"/>
               </a:rPr>
               <a:t>۱</a:t>
             </a:r>
@@ -15734,9 +15477,8 @@
                 <a:solidFill>
                   <a:schemeClr val="tx1"/>
                 </a:solidFill>
-                <a:latin typeface="Vazirmatn" pitchFamily="34" charset="0"/>
-                <a:ea typeface="Vazirmatn" pitchFamily="34" charset="-122"/>
-                <a:cs typeface="Vazirmatn" pitchFamily="34" charset="-120"/>
+                <a:latin typeface="Arial" pitchFamily="34" charset="0"/>
+                <a:cs typeface="Arial" pitchFamily="34" charset="178"/>
               </a:rPr>
               <a:t>موقعیت محرک</a:t>
             </a:r>
@@ -15773,9 +15515,8 @@
                 <a:solidFill>
                   <a:schemeClr val="accent5"/>
                 </a:solidFill>
-                <a:latin typeface="Vazirmatn" pitchFamily="34" charset="0"/>
-                <a:ea typeface="Vazirmatn" pitchFamily="34" charset="-122"/>
-                <a:cs typeface="Vazirmatn" pitchFamily="34" charset="-120"/>
+                <a:latin typeface="Arial" pitchFamily="34" charset="0"/>
+                <a:cs typeface="Arial" pitchFamily="34" charset="178"/>
               </a:rPr>
               <a:t>Trigger</a:t>
             </a:r>
@@ -15836,9 +15577,8 @@
                 <a:solidFill>
                   <a:schemeClr val="accent1"/>
                 </a:solidFill>
-                <a:latin typeface="Vazirmatn" pitchFamily="34" charset="0"/>
-                <a:ea typeface="Vazirmatn" pitchFamily="34" charset="-122"/>
-                <a:cs typeface="Vazirmatn" pitchFamily="34" charset="-120"/>
+                <a:latin typeface="Arial" pitchFamily="34" charset="0"/>
+                <a:cs typeface="Arial" pitchFamily="34" charset="178"/>
               </a:rPr>
               <a:t>۲</a:t>
             </a:r>
@@ -15878,9 +15618,8 @@
                 <a:solidFill>
                   <a:schemeClr val="tx1"/>
                 </a:solidFill>
-                <a:latin typeface="Vazirmatn" pitchFamily="34" charset="0"/>
-                <a:ea typeface="Vazirmatn" pitchFamily="34" charset="-122"/>
-                <a:cs typeface="Vazirmatn" pitchFamily="34" charset="-120"/>
+                <a:latin typeface="Arial" pitchFamily="34" charset="0"/>
+                <a:cs typeface="Arial" pitchFamily="34" charset="178"/>
               </a:rPr>
               <a:t>احساس / آگاهی هیجانی</a:t>
             </a:r>
@@ -15917,9 +15656,8 @@
                 <a:solidFill>
                   <a:schemeClr val="accent5"/>
                 </a:solidFill>
-                <a:latin typeface="Vazirmatn" pitchFamily="34" charset="0"/>
-                <a:ea typeface="Vazirmatn" pitchFamily="34" charset="-122"/>
-                <a:cs typeface="Vazirmatn" pitchFamily="34" charset="-120"/>
+                <a:latin typeface="Arial" pitchFamily="34" charset="0"/>
+                <a:cs typeface="Arial" pitchFamily="34" charset="178"/>
               </a:rPr>
               <a:t>Emotion / Awareness</a:t>
             </a:r>
@@ -15980,9 +15718,8 @@
                 <a:solidFill>
                   <a:schemeClr val="accent1"/>
                 </a:solidFill>
-                <a:latin typeface="Vazirmatn" pitchFamily="34" charset="0"/>
-                <a:ea typeface="Vazirmatn" pitchFamily="34" charset="-122"/>
-                <a:cs typeface="Vazirmatn" pitchFamily="34" charset="-120"/>
+                <a:latin typeface="Arial" pitchFamily="34" charset="0"/>
+                <a:cs typeface="Arial" pitchFamily="34" charset="178"/>
               </a:rPr>
               <a:t>۳</a:t>
             </a:r>
@@ -16022,9 +15759,8 @@
                 <a:solidFill>
                   <a:schemeClr val="tx1"/>
                 </a:solidFill>
-                <a:latin typeface="Vazirmatn" pitchFamily="34" charset="0"/>
-                <a:ea typeface="Vazirmatn" pitchFamily="34" charset="-122"/>
-                <a:cs typeface="Vazirmatn" pitchFamily="34" charset="-120"/>
+                <a:latin typeface="Arial" pitchFamily="34" charset="0"/>
+                <a:cs typeface="Arial" pitchFamily="34" charset="178"/>
               </a:rPr>
               <a:t>صدای منتقد</a:t>
             </a:r>
@@ -16061,9 +15797,8 @@
                 <a:solidFill>
                   <a:schemeClr val="accent5"/>
                 </a:solidFill>
-                <a:latin typeface="Vazirmatn" pitchFamily="34" charset="0"/>
-                <a:ea typeface="Vazirmatn" pitchFamily="34" charset="-122"/>
-                <a:cs typeface="Vazirmatn" pitchFamily="34" charset="-120"/>
+                <a:latin typeface="Arial" pitchFamily="34" charset="0"/>
+                <a:cs typeface="Arial" pitchFamily="34" charset="178"/>
               </a:rPr>
               <a:t>Self-Criticism</a:t>
             </a:r>
@@ -16124,9 +15859,8 @@
                 <a:solidFill>
                   <a:schemeClr val="accent2"/>
                 </a:solidFill>
-                <a:latin typeface="Vazirmatn" pitchFamily="34" charset="0"/>
-                <a:ea typeface="Vazirmatn" pitchFamily="34" charset="-122"/>
-                <a:cs typeface="Vazirmatn" pitchFamily="34" charset="-120"/>
+                <a:latin typeface="Arial" pitchFamily="34" charset="0"/>
+                <a:cs typeface="Arial" pitchFamily="34" charset="178"/>
               </a:rPr>
               <a:t>۴</a:t>
             </a:r>
@@ -16166,9 +15900,8 @@
                 <a:solidFill>
                   <a:schemeClr val="tx1"/>
                 </a:solidFill>
-                <a:latin typeface="Vazirmatn" pitchFamily="34" charset="0"/>
-                <a:ea typeface="Vazirmatn" pitchFamily="34" charset="-122"/>
-                <a:cs typeface="Vazirmatn" pitchFamily="34" charset="-120"/>
+                <a:latin typeface="Arial" pitchFamily="34" charset="0"/>
+                <a:cs typeface="Arial" pitchFamily="34" charset="178"/>
               </a:rPr>
               <a:t>پاسخ متفاوت به خود</a:t>
             </a:r>
@@ -16205,9 +15938,8 @@
                 <a:solidFill>
                   <a:schemeClr val="accent5"/>
                 </a:solidFill>
-                <a:latin typeface="Vazirmatn" pitchFamily="34" charset="0"/>
-                <a:ea typeface="Vazirmatn" pitchFamily="34" charset="-122"/>
-                <a:cs typeface="Vazirmatn" pitchFamily="34" charset="-120"/>
+                <a:latin typeface="Arial" pitchFamily="34" charset="0"/>
+                <a:cs typeface="Arial" pitchFamily="34" charset="178"/>
               </a:rPr>
               <a:t>Self-Compassion / Protection</a:t>
             </a:r>
@@ -16244,9 +15976,8 @@
                 <a:solidFill>
                   <a:schemeClr val="accent3"/>
                 </a:solidFill>
-                <a:latin typeface="Vazirmatn" pitchFamily="34" charset="0"/>
-                <a:ea typeface="Vazirmatn" pitchFamily="34" charset="-122"/>
-                <a:cs typeface="Vazirmatn" pitchFamily="34" charset="-120"/>
+                <a:latin typeface="Arial" pitchFamily="34" charset="0"/>
+                <a:cs typeface="Arial" pitchFamily="34" charset="178"/>
               </a:rPr>
               <a:t>هدف: حذف احساس نیست؛ تغییر پاسخ به منتقد است.</a:t>
             </a:r>
@@ -16283,9 +16014,8 @@
                 <a:solidFill>
                   <a:schemeClr val="accent5"/>
                 </a:solidFill>
-                <a:latin typeface="Vazirmatn" pitchFamily="34" charset="0"/>
-                <a:ea typeface="Vazirmatn" pitchFamily="34" charset="-122"/>
-                <a:cs typeface="Vazirmatn" pitchFamily="34" charset="-120"/>
+                <a:latin typeface="Arial" pitchFamily="34" charset="0"/>
+                <a:cs typeface="Arial" pitchFamily="34" charset="178"/>
               </a:rPr>
               <a:t>Šoková et al., 2025</a:t>
             </a:r>
@@ -16325,9 +16055,8 @@
                 <a:solidFill>
                   <a:schemeClr val="accent5"/>
                 </a:solidFill>
-                <a:latin typeface="Vazirmatn"/>
-                <a:ea typeface="Vazirmatn"/>
-                <a:cs typeface="Vazirmatn"/>
+                <a:latin typeface="Arial"/>
+                <a:cs typeface="Arial"/>
               </a:defRPr>
             </a:lvl1pPr>
           </a:lstStyle>
@@ -16422,9 +16151,8 @@
                 <a:solidFill>
                   <a:schemeClr val="bg1"/>
                 </a:solidFill>
-                <a:latin typeface="Vazirmatn" pitchFamily="34" charset="0"/>
-                <a:ea typeface="Vazirmatn" pitchFamily="34" charset="-122"/>
-                <a:cs typeface="Vazirmatn" pitchFamily="34" charset="-120"/>
+                <a:latin typeface="Arial" pitchFamily="34" charset="0"/>
+                <a:cs typeface="Arial" pitchFamily="34" charset="178"/>
               </a:rPr>
               <a:t>تمرین</a:t>
             </a:r>
@@ -16488,9 +16216,8 @@
                 <a:solidFill>
                   <a:schemeClr val="accent2"/>
                 </a:solidFill>
-                <a:latin typeface="Vazirmatn" pitchFamily="34" charset="0"/>
-                <a:ea typeface="Vazirmatn" pitchFamily="34" charset="-122"/>
-                <a:cs typeface="Vazirmatn" pitchFamily="34" charset="-120"/>
+                <a:latin typeface="Arial" pitchFamily="34" charset="0"/>
+                <a:cs typeface="Arial" pitchFamily="34" charset="178"/>
               </a:rPr>
               <a:t>۸ دقیقه</a:t>
             </a:r>
@@ -16529,9 +16256,8 @@
                 <a:solidFill>
                   <a:schemeClr val="tx2"/>
                 </a:solidFill>
-                <a:latin typeface="Vazirmatn" pitchFamily="34" charset="0"/>
-                <a:ea typeface="Vazirmatn" pitchFamily="34" charset="-122"/>
-                <a:cs typeface="Vazirmatn" pitchFamily="34" charset="-120"/>
+                <a:latin typeface="Arial" pitchFamily="34" charset="0"/>
+                <a:cs typeface="Arial" pitchFamily="34" charset="178"/>
               </a:rPr>
               <a:t>تمرین ۱ | آخرین باری که خودتان را سرزنش کردید</a:t>
             </a:r>
@@ -16588,9 +16314,8 @@
                 <a:solidFill>
                   <a:schemeClr val="bg1"/>
                 </a:solidFill>
-                <a:latin typeface="Vazirmatn" pitchFamily="34" charset="0"/>
-                <a:ea typeface="Vazirmatn" pitchFamily="34" charset="-122"/>
-                <a:cs typeface="Vazirmatn" pitchFamily="34" charset="-120"/>
+                <a:latin typeface="Arial" pitchFamily="34" charset="0"/>
+                <a:cs typeface="Arial" pitchFamily="34" charset="178"/>
               </a:rPr>
               <a:t>۱</a:t>
             </a:r>
@@ -16627,9 +16352,8 @@
                 <a:solidFill>
                   <a:schemeClr val="tx1"/>
                 </a:solidFill>
-                <a:latin typeface="Vazirmatn" pitchFamily="34" charset="0"/>
-                <a:ea typeface="Vazirmatn" pitchFamily="34" charset="-122"/>
-                <a:cs typeface="Vazirmatn" pitchFamily="34" charset="-120"/>
+                <a:latin typeface="Arial" pitchFamily="34" charset="0"/>
+                <a:cs typeface="Arial" pitchFamily="34" charset="178"/>
               </a:rPr>
               <a:t>چه اتفاقی افتاد؟</a:t>
             </a:r>
@@ -16666,9 +16390,8 @@
                 <a:solidFill>
                   <a:schemeClr val="accent5"/>
                 </a:solidFill>
-                <a:latin typeface="Vazirmatn" pitchFamily="34" charset="0"/>
-                <a:ea typeface="Vazirmatn" pitchFamily="34" charset="-122"/>
-                <a:cs typeface="Vazirmatn" pitchFamily="34" charset="-120"/>
+                <a:latin typeface="Arial" pitchFamily="34" charset="0"/>
+                <a:cs typeface="Arial" pitchFamily="34" charset="178"/>
               </a:rPr>
               <a:t>فقط واقعیت.</a:t>
             </a:r>
@@ -16748,9 +16471,8 @@
                 <a:solidFill>
                   <a:schemeClr val="bg1"/>
                 </a:solidFill>
-                <a:latin typeface="Vazirmatn" pitchFamily="34" charset="0"/>
-                <a:ea typeface="Vazirmatn" pitchFamily="34" charset="-122"/>
-                <a:cs typeface="Vazirmatn" pitchFamily="34" charset="-120"/>
+                <a:latin typeface="Arial" pitchFamily="34" charset="0"/>
+                <a:cs typeface="Arial" pitchFamily="34" charset="178"/>
               </a:rPr>
               <a:t>۲</a:t>
             </a:r>
@@ -16787,9 +16509,8 @@
                 <a:solidFill>
                   <a:schemeClr val="tx1"/>
                 </a:solidFill>
-                <a:latin typeface="Vazirmatn" pitchFamily="34" charset="0"/>
-                <a:ea typeface="Vazirmatn" pitchFamily="34" charset="-122"/>
-                <a:cs typeface="Vazirmatn" pitchFamily="34" charset="-120"/>
+                <a:latin typeface="Arial" pitchFamily="34" charset="0"/>
+                <a:cs typeface="Arial" pitchFamily="34" charset="178"/>
               </a:rPr>
               <a:t>اولین احساس شما چه بود؟</a:t>
             </a:r>
@@ -16869,9 +16590,8 @@
                 <a:solidFill>
                   <a:schemeClr val="bg1"/>
                 </a:solidFill>
-                <a:latin typeface="Vazirmatn" pitchFamily="34" charset="0"/>
-                <a:ea typeface="Vazirmatn" pitchFamily="34" charset="-122"/>
-                <a:cs typeface="Vazirmatn" pitchFamily="34" charset="-120"/>
+                <a:latin typeface="Arial" pitchFamily="34" charset="0"/>
+                <a:cs typeface="Arial" pitchFamily="34" charset="178"/>
               </a:rPr>
               <a:t>۳</a:t>
             </a:r>
@@ -16908,9 +16628,8 @@
                 <a:solidFill>
                   <a:schemeClr val="tx1"/>
                 </a:solidFill>
-                <a:latin typeface="Vazirmatn" pitchFamily="34" charset="0"/>
-                <a:ea typeface="Vazirmatn" pitchFamily="34" charset="-122"/>
-                <a:cs typeface="Vazirmatn" pitchFamily="34" charset="-120"/>
+                <a:latin typeface="Arial" pitchFamily="34" charset="0"/>
+                <a:cs typeface="Arial" pitchFamily="34" charset="178"/>
               </a:rPr>
               <a:t>منتقد درونی دقیقاً چه گفت؟</a:t>
             </a:r>
@@ -16990,9 +16709,8 @@
                 <a:solidFill>
                   <a:schemeClr val="bg1"/>
                 </a:solidFill>
-                <a:latin typeface="Vazirmatn" pitchFamily="34" charset="0"/>
-                <a:ea typeface="Vazirmatn" pitchFamily="34" charset="-122"/>
-                <a:cs typeface="Vazirmatn" pitchFamily="34" charset="-120"/>
+                <a:latin typeface="Arial" pitchFamily="34" charset="0"/>
+                <a:cs typeface="Arial" pitchFamily="34" charset="178"/>
               </a:rPr>
               <a:t>۴</a:t>
             </a:r>
@@ -17029,9 +16747,8 @@
                 <a:solidFill>
                   <a:schemeClr val="tx1"/>
                 </a:solidFill>
-                <a:latin typeface="Vazirmatn" pitchFamily="34" charset="0"/>
-                <a:ea typeface="Vazirmatn" pitchFamily="34" charset="-122"/>
-                <a:cs typeface="Vazirmatn" pitchFamily="34" charset="-120"/>
+                <a:latin typeface="Arial" pitchFamily="34" charset="0"/>
+                <a:cs typeface="Arial" pitchFamily="34" charset="178"/>
               </a:rPr>
               <a:t>این صدا بیشتر شبیه کدام الگو بود؟</a:t>
             </a:r>
@@ -17111,9 +16828,8 @@
                 <a:solidFill>
                   <a:schemeClr val="bg1"/>
                 </a:solidFill>
-                <a:latin typeface="Vazirmatn" pitchFamily="34" charset="0"/>
-                <a:ea typeface="Vazirmatn" pitchFamily="34" charset="-122"/>
-                <a:cs typeface="Vazirmatn" pitchFamily="34" charset="-120"/>
+                <a:latin typeface="Arial" pitchFamily="34" charset="0"/>
+                <a:cs typeface="Arial" pitchFamily="34" charset="178"/>
               </a:rPr>
               <a:t>۵</a:t>
             </a:r>
@@ -17150,9 +16866,8 @@
                 <a:solidFill>
                   <a:schemeClr val="tx1"/>
                 </a:solidFill>
-                <a:latin typeface="Vazirmatn" pitchFamily="34" charset="0"/>
-                <a:ea typeface="Vazirmatn" pitchFamily="34" charset="-122"/>
-                <a:cs typeface="Vazirmatn" pitchFamily="34" charset="-120"/>
+                <a:latin typeface="Arial" pitchFamily="34" charset="0"/>
+                <a:cs typeface="Arial" pitchFamily="34" charset="178"/>
               </a:rPr>
               <a:t>اگر قرار نبود خودتان را تنبیه کنید، چه نیازی داشتید؟</a:t>
             </a:r>
@@ -17192,9 +16907,8 @@
                 <a:solidFill>
                   <a:schemeClr val="accent5"/>
                 </a:solidFill>
-                <a:latin typeface="Vazirmatn"/>
-                <a:ea typeface="Vazirmatn"/>
-                <a:cs typeface="Vazirmatn"/>
+                <a:latin typeface="Arial"/>
+                <a:cs typeface="Arial"/>
               </a:defRPr>
             </a:lvl1pPr>
           </a:lstStyle>
@@ -17259,9 +16973,9 @@
     </a:clrScheme>
     <a:fontScheme name="Cinnamon Cedar">
       <a:majorFont>
-        <a:latin typeface="Vazirmatn"/>
+        <a:latin typeface="Arial"/>
         <a:ea typeface=""/>
-        <a:cs typeface="Vazirmatn"/>
+        <a:cs typeface="Arial"/>
         <a:font script="Jpan" typeface="游ゴシック Light"/>
         <a:font script="Hang" typeface="맑은 고딕"/>
         <a:font script="Hans" typeface="等线 Light"/>
@@ -17311,9 +17025,9 @@
         <a:font script="Tfng" typeface="Ebrima"/>
       </a:majorFont>
       <a:minorFont>
-        <a:latin typeface="Vazirmatn"/>
+        <a:latin typeface="Arial"/>
         <a:ea typeface=""/>
-        <a:cs typeface="Vazirmatn"/>
+        <a:cs typeface="Arial"/>
         <a:font script="Jpan" typeface="游ゴシック"/>
         <a:font script="Hang" typeface="맑은 고딕"/>
         <a:font script="Hans" typeface="等线"/>

</xml_diff>